<commit_message>
Final group meeting presentation changes/additions
</commit_message>
<xml_diff>
--- a/presentations/2026-02-20.pptx
+++ b/presentations/2026-02-20.pptx
@@ -5,7 +5,7 @@
     <p:sldMasterId id="2147483648" r:id="rId1"/>
   </p:sldMasterIdLst>
   <p:notesMasterIdLst>
-    <p:notesMasterId r:id="rId25"/>
+    <p:notesMasterId r:id="rId27"/>
   </p:notesMasterIdLst>
   <p:sldIdLst>
     <p:sldId id="256" r:id="rId4"/>
@@ -29,6 +29,8 @@
     <p:sldId id="274" r:id="rId22"/>
     <p:sldId id="275" r:id="rId23"/>
     <p:sldId id="276" r:id="rId24"/>
+    <p:sldId id="277" r:id="rId25"/>
+    <p:sldId id="278" r:id="rId26"/>
   </p:sldIdLst>
   <p:sldSz cx="9144000" cy="5143500" type="screen16x9"/>
   <p:notesSz cx="6858000" cy="9144000"/>
@@ -184,7 +186,7 @@
       </p:grpSpPr>
       <p:sp>
         <p:nvSpPr>
-          <p:cNvPr id="1550542681" name="Header Placeholder 1"/>
+          <p:cNvPr id="1519079572" name="Header Placeholder 1"/>
           <p:cNvSpPr>
             <a:spLocks noGrp="1"/>
           </p:cNvSpPr>
@@ -218,7 +220,7 @@
       </p:sp>
       <p:sp>
         <p:nvSpPr>
-          <p:cNvPr id="162610478" name="Date Placeholder 2"/>
+          <p:cNvPr id="520444872" name="Date Placeholder 2"/>
           <p:cNvSpPr>
             <a:spLocks noGrp="1"/>
           </p:cNvSpPr>
@@ -252,7 +254,7 @@
       </p:sp>
       <p:sp>
         <p:nvSpPr>
-          <p:cNvPr id="606069587" name="Date Placeholder 2"/>
+          <p:cNvPr id="601286796" name="Date Placeholder 2"/>
           <p:cNvSpPr>
             <a:spLocks noGrp="1"/>
           </p:cNvSpPr>
@@ -286,7 +288,7 @@
       </p:sp>
       <p:sp>
         <p:nvSpPr>
-          <p:cNvPr id="1716787660" name="Notes Placeholder 4"/>
+          <p:cNvPr id="709438061" name="Notes Placeholder 4"/>
           <p:cNvSpPr>
             <a:spLocks noGrp="1"/>
           </p:cNvSpPr>
@@ -316,7 +318,7 @@
       </p:sp>
       <p:sp>
         <p:nvSpPr>
-          <p:cNvPr id="1792568485" name="Footer Placeholder 5"/>
+          <p:cNvPr id="1828496941" name="Footer Placeholder 5"/>
           <p:cNvSpPr>
             <a:spLocks noGrp="1"/>
           </p:cNvSpPr>
@@ -350,7 +352,7 @@
       </p:sp>
       <p:sp>
         <p:nvSpPr>
-          <p:cNvPr id="1302346024" name="Slide Number Placeholder 6"/>
+          <p:cNvPr id="1281025029" name="Slide Number Placeholder 6"/>
           <p:cNvSpPr>
             <a:spLocks noGrp="1"/>
           </p:cNvSpPr>
@@ -499,7 +501,7 @@
       </p:grpSpPr>
       <p:sp>
         <p:nvSpPr>
-          <p:cNvPr id="1846639021" name="Slide Image Placeholder 1"/>
+          <p:cNvPr id="1303374922" name="Slide Image Placeholder 1"/>
           <p:cNvSpPr>
             <a:spLocks noChangeAspect="1" noGrp="1" noRot="1"/>
           </p:cNvSpPr>
@@ -511,7 +513,7 @@
       </p:sp>
       <p:sp>
         <p:nvSpPr>
-          <p:cNvPr id="1896704106" name="Notes Placeholder 2"/>
+          <p:cNvPr id="1661167987" name="Notes Placeholder 2"/>
           <p:cNvSpPr>
             <a:spLocks noGrp="1"/>
           </p:cNvSpPr>
@@ -533,7 +535,7 @@
       </p:sp>
       <p:sp>
         <p:nvSpPr>
-          <p:cNvPr id="167516333" name="Slide Number Placeholder 3"/>
+          <p:cNvPr id="1892561615" name="Slide Number Placeholder 3"/>
           <p:cNvSpPr>
             <a:spLocks noGrp="1"/>
           </p:cNvSpPr>
@@ -584,7 +586,7 @@
       </p:grpSpPr>
       <p:sp>
         <p:nvSpPr>
-          <p:cNvPr id="1128612640" name="Slide Image Placeholder 1"/>
+          <p:cNvPr id="2143943698" name="Slide Image Placeholder 1"/>
           <p:cNvSpPr>
             <a:spLocks noChangeAspect="1" noGrp="1" noRot="1"/>
           </p:cNvSpPr>
@@ -596,7 +598,7 @@
       </p:sp>
       <p:sp>
         <p:nvSpPr>
-          <p:cNvPr id="1241779153" name="Notes Placeholder 2"/>
+          <p:cNvPr id="235322564" name="Notes Placeholder 2"/>
           <p:cNvSpPr>
             <a:spLocks noGrp="1"/>
           </p:cNvSpPr>
@@ -618,7 +620,7 @@
       </p:sp>
       <p:sp>
         <p:nvSpPr>
-          <p:cNvPr id="935588317" name="Slide Number Placeholder 3"/>
+          <p:cNvPr id="974792075" name="Slide Number Placeholder 3"/>
           <p:cNvSpPr>
             <a:spLocks noGrp="1"/>
           </p:cNvSpPr>
@@ -669,7 +671,7 @@
       </p:grpSpPr>
       <p:sp>
         <p:nvSpPr>
-          <p:cNvPr id="1555600543" name="Slide Image Placeholder 1"/>
+          <p:cNvPr id="325353526" name="Slide Image Placeholder 1"/>
           <p:cNvSpPr>
             <a:spLocks noChangeAspect="1" noGrp="1" noRot="1"/>
           </p:cNvSpPr>
@@ -681,7 +683,7 @@
       </p:sp>
       <p:sp>
         <p:nvSpPr>
-          <p:cNvPr id="1876076705" name="Notes Placeholder 2"/>
+          <p:cNvPr id="395056922" name="Notes Placeholder 2"/>
           <p:cNvSpPr>
             <a:spLocks noGrp="1"/>
           </p:cNvSpPr>
@@ -703,7 +705,7 @@
       </p:sp>
       <p:sp>
         <p:nvSpPr>
-          <p:cNvPr id="429402141" name="Slide Number Placeholder 3"/>
+          <p:cNvPr id="878732748" name="Slide Number Placeholder 3"/>
           <p:cNvSpPr>
             <a:spLocks noGrp="1"/>
           </p:cNvSpPr>
@@ -754,7 +756,7 @@
       </p:grpSpPr>
       <p:sp>
         <p:nvSpPr>
-          <p:cNvPr id="2" name="Slide Image Placeholder 1"/>
+          <p:cNvPr id="1749935688" name="Slide Image Placeholder 1"/>
           <p:cNvSpPr>
             <a:spLocks noChangeAspect="1" noGrp="1" noRot="1"/>
           </p:cNvSpPr>
@@ -766,7 +768,7 @@
       </p:sp>
       <p:sp>
         <p:nvSpPr>
-          <p:cNvPr id="3" name="Notes Placeholder 2"/>
+          <p:cNvPr id="908476624" name="Notes Placeholder 2"/>
           <p:cNvSpPr>
             <a:spLocks noGrp="1"/>
           </p:cNvSpPr>
@@ -788,7 +790,7 @@
       </p:sp>
       <p:sp>
         <p:nvSpPr>
-          <p:cNvPr id="4" name="Slide Number Placeholder 3"/>
+          <p:cNvPr id="1459348026" name="Slide Number Placeholder 3"/>
           <p:cNvSpPr>
             <a:spLocks noGrp="1"/>
           </p:cNvSpPr>
@@ -839,7 +841,7 @@
       </p:grpSpPr>
       <p:sp>
         <p:nvSpPr>
-          <p:cNvPr id="1757907702" name="Slide Image Placeholder 1"/>
+          <p:cNvPr id="1665323493" name="Slide Image Placeholder 1"/>
           <p:cNvSpPr>
             <a:spLocks noChangeAspect="1" noGrp="1" noRot="1"/>
           </p:cNvSpPr>
@@ -851,7 +853,7 @@
       </p:sp>
       <p:sp>
         <p:nvSpPr>
-          <p:cNvPr id="2066442806" name="Notes Placeholder 2"/>
+          <p:cNvPr id="1862772436" name="Notes Placeholder 2"/>
           <p:cNvSpPr>
             <a:spLocks noGrp="1"/>
           </p:cNvSpPr>
@@ -873,7 +875,7 @@
       </p:sp>
       <p:sp>
         <p:nvSpPr>
-          <p:cNvPr id="1503983838" name="Slide Number Placeholder 3"/>
+          <p:cNvPr id="1752012083" name="Slide Number Placeholder 3"/>
           <p:cNvSpPr>
             <a:spLocks noGrp="1"/>
           </p:cNvSpPr>
@@ -924,7 +926,7 @@
       </p:grpSpPr>
       <p:sp>
         <p:nvSpPr>
-          <p:cNvPr id="156876853" name="Slide Image Placeholder 1"/>
+          <p:cNvPr id="351028379" name="Slide Image Placeholder 1"/>
           <p:cNvSpPr>
             <a:spLocks noChangeAspect="1" noGrp="1" noRot="1"/>
           </p:cNvSpPr>
@@ -936,7 +938,7 @@
       </p:sp>
       <p:sp>
         <p:nvSpPr>
-          <p:cNvPr id="577554512" name="Notes Placeholder 2"/>
+          <p:cNvPr id="299543288" name="Notes Placeholder 2"/>
           <p:cNvSpPr>
             <a:spLocks noGrp="1"/>
           </p:cNvSpPr>
@@ -958,7 +960,7 @@
       </p:sp>
       <p:sp>
         <p:nvSpPr>
-          <p:cNvPr id="1636418395" name="Slide Number Placeholder 3"/>
+          <p:cNvPr id="1951396283" name="Slide Number Placeholder 3"/>
           <p:cNvSpPr>
             <a:spLocks noGrp="1"/>
           </p:cNvSpPr>
@@ -1009,7 +1011,7 @@
       </p:grpSpPr>
       <p:sp>
         <p:nvSpPr>
-          <p:cNvPr id="979175240" name="Slide Image Placeholder 1"/>
+          <p:cNvPr id="2" name="Slide Image Placeholder 1"/>
           <p:cNvSpPr>
             <a:spLocks noChangeAspect="1" noGrp="1" noRot="1"/>
           </p:cNvSpPr>
@@ -1021,7 +1023,7 @@
       </p:sp>
       <p:sp>
         <p:nvSpPr>
-          <p:cNvPr id="1496571199" name="Notes Placeholder 2"/>
+          <p:cNvPr id="3" name="Notes Placeholder 2"/>
           <p:cNvSpPr>
             <a:spLocks noGrp="1"/>
           </p:cNvSpPr>
@@ -1043,7 +1045,7 @@
       </p:sp>
       <p:sp>
         <p:nvSpPr>
-          <p:cNvPr id="695168407" name="Slide Number Placeholder 3"/>
+          <p:cNvPr id="4" name="Slide Number Placeholder 3"/>
           <p:cNvSpPr>
             <a:spLocks noGrp="1"/>
           </p:cNvSpPr>
@@ -1059,7 +1061,7 @@
             <a:pPr>
               <a:defRPr/>
             </a:pPr>
-            <a:fld id="{00FC7E35-A03A-8B2E-A9BB-E70D8B958680}" type="slidenum">
+            <a:fld id="{31319FC7-B2F0-C779-CB28-681B3598883F}" type="slidenum">
               <a:rPr/>
               <a:t/>
             </a:fld>
@@ -1144,7 +1146,7 @@
             <a:pPr>
               <a:defRPr/>
             </a:pPr>
-            <a:fld id="{09C3723D-1BE3-26CD-799B-A4B604D7ECF9}" type="slidenum">
+            <a:fld id="{BD1C831F-5362-E660-8933-CCF7D53F0504}" type="slidenum">
               <a:rPr/>
               <a:t/>
             </a:fld>
@@ -1179,7 +1181,7 @@
       </p:grpSpPr>
       <p:sp>
         <p:nvSpPr>
-          <p:cNvPr id="2" name="Slide Image Placeholder 1"/>
+          <p:cNvPr id="851182584" name="Slide Image Placeholder 1"/>
           <p:cNvSpPr>
             <a:spLocks noChangeAspect="1" noGrp="1" noRot="1"/>
           </p:cNvSpPr>
@@ -1191,7 +1193,7 @@
       </p:sp>
       <p:sp>
         <p:nvSpPr>
-          <p:cNvPr id="3" name="Notes Placeholder 2"/>
+          <p:cNvPr id="355411535" name="Notes Placeholder 2"/>
           <p:cNvSpPr>
             <a:spLocks noGrp="1"/>
           </p:cNvSpPr>
@@ -1213,7 +1215,7 @@
       </p:sp>
       <p:sp>
         <p:nvSpPr>
-          <p:cNvPr id="4" name="Slide Number Placeholder 3"/>
+          <p:cNvPr id="850104491" name="Slide Number Placeholder 3"/>
           <p:cNvSpPr>
             <a:spLocks noGrp="1"/>
           </p:cNvSpPr>
@@ -1229,7 +1231,7 @@
             <a:pPr>
               <a:defRPr/>
             </a:pPr>
-            <a:fld id="{B7F13005-4EBF-EBCC-59F0-698E62E32F98}" type="slidenum">
+            <a:fld id="{00FC7E35-A03A-8B2E-A9BB-E70D8B958680}" type="slidenum">
               <a:rPr/>
               <a:t/>
             </a:fld>
@@ -1264,7 +1266,7 @@
       </p:grpSpPr>
       <p:sp>
         <p:nvSpPr>
-          <p:cNvPr id="1668622573" name="Slide Image Placeholder 1"/>
+          <p:cNvPr id="794632358" name="Slide Image Placeholder 1"/>
           <p:cNvSpPr>
             <a:spLocks noChangeAspect="1" noGrp="1" noRot="1"/>
           </p:cNvSpPr>
@@ -1276,7 +1278,7 @@
       </p:sp>
       <p:sp>
         <p:nvSpPr>
-          <p:cNvPr id="1126707755" name="Notes Placeholder 2"/>
+          <p:cNvPr id="634449036" name="Notes Placeholder 2"/>
           <p:cNvSpPr>
             <a:spLocks noGrp="1"/>
           </p:cNvSpPr>
@@ -1298,7 +1300,7 @@
       </p:sp>
       <p:sp>
         <p:nvSpPr>
-          <p:cNvPr id="1976103251" name="Slide Number Placeholder 3"/>
+          <p:cNvPr id="434904577" name="Slide Number Placeholder 3"/>
           <p:cNvSpPr>
             <a:spLocks noGrp="1"/>
           </p:cNvSpPr>
@@ -1314,7 +1316,7 @@
             <a:pPr>
               <a:defRPr/>
             </a:pPr>
-            <a:fld id="{4883DAB9-263E-99C2-3148-D85E9764752F}" type="slidenum">
+            <a:fld id="{09C3723D-1BE3-26CD-799B-A4B604D7ECF9}" type="slidenum">
               <a:rPr/>
               <a:t/>
             </a:fld>
@@ -1349,7 +1351,7 @@
       </p:grpSpPr>
       <p:sp>
         <p:nvSpPr>
-          <p:cNvPr id="1688732821" name="Slide Image Placeholder 1"/>
+          <p:cNvPr id="119154914" name="Slide Image Placeholder 1"/>
           <p:cNvSpPr>
             <a:spLocks noChangeAspect="1" noGrp="1" noRot="1"/>
           </p:cNvSpPr>
@@ -1361,7 +1363,7 @@
       </p:sp>
       <p:sp>
         <p:nvSpPr>
-          <p:cNvPr id="768567516" name="Notes Placeholder 2"/>
+          <p:cNvPr id="77411983" name="Notes Placeholder 2"/>
           <p:cNvSpPr>
             <a:spLocks noGrp="1"/>
           </p:cNvSpPr>
@@ -1383,7 +1385,7 @@
       </p:sp>
       <p:sp>
         <p:nvSpPr>
-          <p:cNvPr id="1232422802" name="Slide Number Placeholder 3"/>
+          <p:cNvPr id="1242344159" name="Slide Number Placeholder 3"/>
           <p:cNvSpPr>
             <a:spLocks noGrp="1"/>
           </p:cNvSpPr>
@@ -1399,7 +1401,7 @@
             <a:pPr>
               <a:defRPr/>
             </a:pPr>
-            <a:fld id="{940BC1F9-FEF1-FA24-DFEC-C66E3F61FA24}" type="slidenum">
+            <a:fld id="{B7F13005-4EBF-EBCC-59F0-698E62E32F98}" type="slidenum">
               <a:rPr/>
               <a:t/>
             </a:fld>
@@ -1434,7 +1436,7 @@
       </p:grpSpPr>
       <p:sp>
         <p:nvSpPr>
-          <p:cNvPr id="1561181778" name="Slide Image Placeholder 1"/>
+          <p:cNvPr id="823390639" name="Slide Image Placeholder 1"/>
           <p:cNvSpPr>
             <a:spLocks noChangeAspect="1" noGrp="1" noRot="1"/>
           </p:cNvSpPr>
@@ -1446,7 +1448,7 @@
       </p:sp>
       <p:sp>
         <p:nvSpPr>
-          <p:cNvPr id="652581446" name="Notes Placeholder 2"/>
+          <p:cNvPr id="1581279531" name="Notes Placeholder 2"/>
           <p:cNvSpPr>
             <a:spLocks noGrp="1"/>
           </p:cNvSpPr>
@@ -1468,7 +1470,7 @@
       </p:sp>
       <p:sp>
         <p:nvSpPr>
-          <p:cNvPr id="35726055" name="Slide Number Placeholder 3"/>
+          <p:cNvPr id="1292308873" name="Slide Number Placeholder 3"/>
           <p:cNvSpPr>
             <a:spLocks noGrp="1"/>
           </p:cNvSpPr>
@@ -1519,7 +1521,7 @@
       </p:grpSpPr>
       <p:sp>
         <p:nvSpPr>
-          <p:cNvPr id="790740513" name="Slide Image Placeholder 1"/>
+          <p:cNvPr id="1202536163" name="Slide Image Placeholder 1"/>
           <p:cNvSpPr>
             <a:spLocks noChangeAspect="1" noGrp="1" noRot="1"/>
           </p:cNvSpPr>
@@ -1531,7 +1533,7 @@
       </p:sp>
       <p:sp>
         <p:nvSpPr>
-          <p:cNvPr id="753089654" name="Notes Placeholder 2"/>
+          <p:cNvPr id="114181163" name="Notes Placeholder 2"/>
           <p:cNvSpPr>
             <a:spLocks noGrp="1"/>
           </p:cNvSpPr>
@@ -1553,7 +1555,7 @@
       </p:sp>
       <p:sp>
         <p:nvSpPr>
-          <p:cNvPr id="974842872" name="Slide Number Placeholder 3"/>
+          <p:cNvPr id="2049489597" name="Slide Number Placeholder 3"/>
           <p:cNvSpPr>
             <a:spLocks noGrp="1"/>
           </p:cNvSpPr>
@@ -1569,7 +1571,7 @@
             <a:pPr>
               <a:defRPr/>
             </a:pPr>
-            <a:fld id="{0468C8CC-28AA-B9D6-78BE-E7EA431A471E}" type="slidenum">
+            <a:fld id="{4883DAB9-263E-99C2-3148-D85E9764752F}" type="slidenum">
               <a:rPr/>
               <a:t/>
             </a:fld>
@@ -1604,7 +1606,7 @@
       </p:grpSpPr>
       <p:sp>
         <p:nvSpPr>
-          <p:cNvPr id="44671864" name="Slide Image Placeholder 1"/>
+          <p:cNvPr id="262229761" name="Slide Image Placeholder 1"/>
           <p:cNvSpPr>
             <a:spLocks noChangeAspect="1" noGrp="1" noRot="1"/>
           </p:cNvSpPr>
@@ -1616,7 +1618,7 @@
       </p:sp>
       <p:sp>
         <p:nvSpPr>
-          <p:cNvPr id="676014015" name="Notes Placeholder 2"/>
+          <p:cNvPr id="412205859" name="Notes Placeholder 2"/>
           <p:cNvSpPr>
             <a:spLocks noGrp="1"/>
           </p:cNvSpPr>
@@ -1638,7 +1640,177 @@
       </p:sp>
       <p:sp>
         <p:nvSpPr>
-          <p:cNvPr id="550324892" name="Slide Number Placeholder 3"/>
+          <p:cNvPr id="2065405172" name="Slide Number Placeholder 3"/>
+          <p:cNvSpPr>
+            <a:spLocks noGrp="1"/>
+          </p:cNvSpPr>
+          <p:nvPr>
+            <p:ph type="sldNum" sz="quarter" idx="10"/>
+          </p:nvPr>
+        </p:nvSpPr>
+        <p:spPr bwMode="auto"/>
+        <p:txBody>
+          <a:bodyPr/>
+          <a:lstStyle/>
+          <a:p>
+            <a:pPr>
+              <a:defRPr/>
+            </a:pPr>
+            <a:fld id="{940BC1F9-FEF1-FA24-DFEC-C66E3F61FA24}" type="slidenum">
+              <a:rPr/>
+              <a:t/>
+            </a:fld>
+            <a:endParaRPr/>
+          </a:p>
+        </p:txBody>
+      </p:sp>
+    </p:spTree>
+  </p:cSld>
+  <p:clrMapOvr>
+    <a:masterClrMapping/>
+  </p:clrMapOvr>
+</p:notes>
+</file>
+
+<file path=ppt/notesSlides/notesSlide22.xml><?xml version="1.0" encoding="utf-8"?>
+<p:notes xmlns:a="http://schemas.openxmlformats.org/drawingml/2006/main" xmlns:r="http://schemas.openxmlformats.org/officeDocument/2006/relationships" xmlns:p="http://schemas.openxmlformats.org/presentationml/2006/main" xmlns:m="http://schemas.openxmlformats.org/officeDocument/2006/math" xmlns:w="http://schemas.openxmlformats.org/wordprocessingml/2006/main">
+  <p:cSld name="">
+    <p:spTree>
+      <p:nvGrpSpPr>
+        <p:cNvPr id="1" name=""/>
+        <p:cNvGrpSpPr/>
+        <p:nvPr/>
+      </p:nvGrpSpPr>
+      <p:grpSpPr bwMode="auto">
+        <a:xfrm>
+          <a:off x="0" y="0"/>
+          <a:ext cx="0" cy="0"/>
+          <a:chOff x="0" y="0"/>
+          <a:chExt cx="0" cy="0"/>
+        </a:xfrm>
+      </p:grpSpPr>
+      <p:sp>
+        <p:nvSpPr>
+          <p:cNvPr id="1734891194" name="Slide Image Placeholder 1"/>
+          <p:cNvSpPr>
+            <a:spLocks noChangeAspect="1" noGrp="1" noRot="1"/>
+          </p:cNvSpPr>
+          <p:nvPr>
+            <p:ph type="sldImg"/>
+          </p:nvPr>
+        </p:nvSpPr>
+        <p:spPr bwMode="auto"/>
+      </p:sp>
+      <p:sp>
+        <p:nvSpPr>
+          <p:cNvPr id="831716122" name="Notes Placeholder 2"/>
+          <p:cNvSpPr>
+            <a:spLocks noGrp="1"/>
+          </p:cNvSpPr>
+          <p:nvPr>
+            <p:ph type="body" idx="1"/>
+          </p:nvPr>
+        </p:nvSpPr>
+        <p:spPr bwMode="auto"/>
+        <p:txBody>
+          <a:bodyPr/>
+          <a:lstStyle/>
+          <a:p>
+            <a:pPr>
+              <a:defRPr/>
+            </a:pPr>
+            <a:endParaRPr/>
+          </a:p>
+        </p:txBody>
+      </p:sp>
+      <p:sp>
+        <p:nvSpPr>
+          <p:cNvPr id="1805844981" name="Slide Number Placeholder 3"/>
+          <p:cNvSpPr>
+            <a:spLocks noGrp="1"/>
+          </p:cNvSpPr>
+          <p:nvPr>
+            <p:ph type="sldNum" sz="quarter" idx="10"/>
+          </p:nvPr>
+        </p:nvSpPr>
+        <p:spPr bwMode="auto"/>
+        <p:txBody>
+          <a:bodyPr/>
+          <a:lstStyle/>
+          <a:p>
+            <a:pPr>
+              <a:defRPr/>
+            </a:pPr>
+            <a:fld id="{0468C8CC-28AA-B9D6-78BE-E7EA431A471E}" type="slidenum">
+              <a:rPr/>
+              <a:t/>
+            </a:fld>
+            <a:endParaRPr/>
+          </a:p>
+        </p:txBody>
+      </p:sp>
+    </p:spTree>
+  </p:cSld>
+  <p:clrMapOvr>
+    <a:masterClrMapping/>
+  </p:clrMapOvr>
+</p:notes>
+</file>
+
+<file path=ppt/notesSlides/notesSlide23.xml><?xml version="1.0" encoding="utf-8"?>
+<p:notes xmlns:a="http://schemas.openxmlformats.org/drawingml/2006/main" xmlns:r="http://schemas.openxmlformats.org/officeDocument/2006/relationships" xmlns:p="http://schemas.openxmlformats.org/presentationml/2006/main" xmlns:m="http://schemas.openxmlformats.org/officeDocument/2006/math" xmlns:w="http://schemas.openxmlformats.org/wordprocessingml/2006/main">
+  <p:cSld name="">
+    <p:spTree>
+      <p:nvGrpSpPr>
+        <p:cNvPr id="1" name=""/>
+        <p:cNvGrpSpPr/>
+        <p:nvPr/>
+      </p:nvGrpSpPr>
+      <p:grpSpPr bwMode="auto">
+        <a:xfrm>
+          <a:off x="0" y="0"/>
+          <a:ext cx="0" cy="0"/>
+          <a:chOff x="0" y="0"/>
+          <a:chExt cx="0" cy="0"/>
+        </a:xfrm>
+      </p:grpSpPr>
+      <p:sp>
+        <p:nvSpPr>
+          <p:cNvPr id="268849631" name="Slide Image Placeholder 1"/>
+          <p:cNvSpPr>
+            <a:spLocks noChangeAspect="1" noGrp="1" noRot="1"/>
+          </p:cNvSpPr>
+          <p:nvPr>
+            <p:ph type="sldImg"/>
+          </p:nvPr>
+        </p:nvSpPr>
+        <p:spPr bwMode="auto"/>
+      </p:sp>
+      <p:sp>
+        <p:nvSpPr>
+          <p:cNvPr id="1331669384" name="Notes Placeholder 2"/>
+          <p:cNvSpPr>
+            <a:spLocks noGrp="1"/>
+          </p:cNvSpPr>
+          <p:nvPr>
+            <p:ph type="body" idx="1"/>
+          </p:nvPr>
+        </p:nvSpPr>
+        <p:spPr bwMode="auto"/>
+        <p:txBody>
+          <a:bodyPr/>
+          <a:lstStyle/>
+          <a:p>
+            <a:pPr>
+              <a:defRPr/>
+            </a:pPr>
+            <a:endParaRPr/>
+          </a:p>
+        </p:txBody>
+      </p:sp>
+      <p:sp>
+        <p:nvSpPr>
+          <p:cNvPr id="771783863" name="Slide Number Placeholder 3"/>
           <p:cNvSpPr>
             <a:spLocks noGrp="1"/>
           </p:cNvSpPr>
@@ -1689,7 +1861,7 @@
       </p:grpSpPr>
       <p:sp>
         <p:nvSpPr>
-          <p:cNvPr id="1169483068" name="Slide Image Placeholder 1"/>
+          <p:cNvPr id="1970703256" name="Slide Image Placeholder 1"/>
           <p:cNvSpPr>
             <a:spLocks noChangeAspect="1" noGrp="1" noRot="1"/>
           </p:cNvSpPr>
@@ -1701,7 +1873,7 @@
       </p:sp>
       <p:sp>
         <p:nvSpPr>
-          <p:cNvPr id="761867712" name="Notes Placeholder 2"/>
+          <p:cNvPr id="982785342" name="Notes Placeholder 2"/>
           <p:cNvSpPr>
             <a:spLocks noGrp="1"/>
           </p:cNvSpPr>
@@ -1723,7 +1895,7 @@
       </p:sp>
       <p:sp>
         <p:nvSpPr>
-          <p:cNvPr id="655376656" name="Slide Number Placeholder 3"/>
+          <p:cNvPr id="1573956731" name="Slide Number Placeholder 3"/>
           <p:cNvSpPr>
             <a:spLocks noGrp="1"/>
           </p:cNvSpPr>
@@ -1774,7 +1946,7 @@
       </p:grpSpPr>
       <p:sp>
         <p:nvSpPr>
-          <p:cNvPr id="1631254330" name="Slide Image Placeholder 1"/>
+          <p:cNvPr id="582815765" name="Slide Image Placeholder 1"/>
           <p:cNvSpPr>
             <a:spLocks noChangeAspect="1" noGrp="1" noRot="1"/>
           </p:cNvSpPr>
@@ -1786,7 +1958,7 @@
       </p:sp>
       <p:sp>
         <p:nvSpPr>
-          <p:cNvPr id="1980086973" name="Notes Placeholder 2"/>
+          <p:cNvPr id="1387673540" name="Notes Placeholder 2"/>
           <p:cNvSpPr>
             <a:spLocks noGrp="1"/>
           </p:cNvSpPr>
@@ -1808,7 +1980,7 @@
       </p:sp>
       <p:sp>
         <p:nvSpPr>
-          <p:cNvPr id="85209542" name="Slide Number Placeholder 3"/>
+          <p:cNvPr id="1219458570" name="Slide Number Placeholder 3"/>
           <p:cNvSpPr>
             <a:spLocks noGrp="1"/>
           </p:cNvSpPr>
@@ -1859,7 +2031,7 @@
       </p:grpSpPr>
       <p:sp>
         <p:nvSpPr>
-          <p:cNvPr id="1535334858" name="Slide Image Placeholder 1"/>
+          <p:cNvPr id="681832995" name="Slide Image Placeholder 1"/>
           <p:cNvSpPr>
             <a:spLocks noChangeAspect="1" noGrp="1" noRot="1"/>
           </p:cNvSpPr>
@@ -1871,7 +2043,7 @@
       </p:sp>
       <p:sp>
         <p:nvSpPr>
-          <p:cNvPr id="424997660" name="Notes Placeholder 2"/>
+          <p:cNvPr id="743614377" name="Notes Placeholder 2"/>
           <p:cNvSpPr>
             <a:spLocks noGrp="1"/>
           </p:cNvSpPr>
@@ -1893,7 +2065,7 @@
       </p:sp>
       <p:sp>
         <p:nvSpPr>
-          <p:cNvPr id="324945356" name="Slide Number Placeholder 3"/>
+          <p:cNvPr id="261392512" name="Slide Number Placeholder 3"/>
           <p:cNvSpPr>
             <a:spLocks noGrp="1"/>
           </p:cNvSpPr>
@@ -1944,7 +2116,7 @@
       </p:grpSpPr>
       <p:sp>
         <p:nvSpPr>
-          <p:cNvPr id="775678559" name="Slide Image Placeholder 1"/>
+          <p:cNvPr id="443071060" name="Slide Image Placeholder 1"/>
           <p:cNvSpPr>
             <a:spLocks noChangeAspect="1" noGrp="1" noRot="1"/>
           </p:cNvSpPr>
@@ -1956,7 +2128,7 @@
       </p:sp>
       <p:sp>
         <p:nvSpPr>
-          <p:cNvPr id="1895594710" name="Notes Placeholder 2"/>
+          <p:cNvPr id="1934246251" name="Notes Placeholder 2"/>
           <p:cNvSpPr>
             <a:spLocks noGrp="1"/>
           </p:cNvSpPr>
@@ -1978,7 +2150,7 @@
       </p:sp>
       <p:sp>
         <p:nvSpPr>
-          <p:cNvPr id="1994535978" name="Slide Number Placeholder 3"/>
+          <p:cNvPr id="905331536" name="Slide Number Placeholder 3"/>
           <p:cNvSpPr>
             <a:spLocks noGrp="1"/>
           </p:cNvSpPr>
@@ -2029,7 +2201,7 @@
       </p:grpSpPr>
       <p:sp>
         <p:nvSpPr>
-          <p:cNvPr id="1058204242" name="Slide Image Placeholder 1"/>
+          <p:cNvPr id="965195018" name="Slide Image Placeholder 1"/>
           <p:cNvSpPr>
             <a:spLocks noChangeAspect="1" noGrp="1" noRot="1"/>
           </p:cNvSpPr>
@@ -2041,7 +2213,7 @@
       </p:sp>
       <p:sp>
         <p:nvSpPr>
-          <p:cNvPr id="1903638984" name="Notes Placeholder 2"/>
+          <p:cNvPr id="892938064" name="Notes Placeholder 2"/>
           <p:cNvSpPr>
             <a:spLocks noGrp="1"/>
           </p:cNvSpPr>
@@ -2063,7 +2235,7 @@
       </p:sp>
       <p:sp>
         <p:nvSpPr>
-          <p:cNvPr id="2000807020" name="Slide Number Placeholder 3"/>
+          <p:cNvPr id="113808206" name="Slide Number Placeholder 3"/>
           <p:cNvSpPr>
             <a:spLocks noGrp="1"/>
           </p:cNvSpPr>
@@ -2114,7 +2286,7 @@
       </p:grpSpPr>
       <p:sp>
         <p:nvSpPr>
-          <p:cNvPr id="1443038378" name="Slide Image Placeholder 1"/>
+          <p:cNvPr id="16687116" name="Slide Image Placeholder 1"/>
           <p:cNvSpPr>
             <a:spLocks noChangeAspect="1" noGrp="1" noRot="1"/>
           </p:cNvSpPr>
@@ -2126,7 +2298,7 @@
       </p:sp>
       <p:sp>
         <p:nvSpPr>
-          <p:cNvPr id="564358191" name="Notes Placeholder 2"/>
+          <p:cNvPr id="1595912456" name="Notes Placeholder 2"/>
           <p:cNvSpPr>
             <a:spLocks noGrp="1"/>
           </p:cNvSpPr>
@@ -2148,7 +2320,7 @@
       </p:sp>
       <p:sp>
         <p:nvSpPr>
-          <p:cNvPr id="264060291" name="Slide Number Placeholder 3"/>
+          <p:cNvPr id="435334323" name="Slide Number Placeholder 3"/>
           <p:cNvSpPr>
             <a:spLocks noGrp="1"/>
           </p:cNvSpPr>
@@ -2199,7 +2371,7 @@
       </p:grpSpPr>
       <p:sp>
         <p:nvSpPr>
-          <p:cNvPr id="1704318214" name="Slide Image Placeholder 1"/>
+          <p:cNvPr id="1265410391" name="Slide Image Placeholder 1"/>
           <p:cNvSpPr>
             <a:spLocks noChangeAspect="1" noGrp="1" noRot="1"/>
           </p:cNvSpPr>
@@ -2211,7 +2383,7 @@
       </p:sp>
       <p:sp>
         <p:nvSpPr>
-          <p:cNvPr id="1311068348" name="Notes Placeholder 2"/>
+          <p:cNvPr id="1438769558" name="Notes Placeholder 2"/>
           <p:cNvSpPr>
             <a:spLocks noGrp="1"/>
           </p:cNvSpPr>
@@ -2233,7 +2405,7 @@
       </p:sp>
       <p:sp>
         <p:nvSpPr>
-          <p:cNvPr id="642072363" name="Slide Number Placeholder 3"/>
+          <p:cNvPr id="1953872618" name="Slide Number Placeholder 3"/>
           <p:cNvSpPr>
             <a:spLocks noGrp="1"/>
           </p:cNvSpPr>
@@ -2284,7 +2456,7 @@
       </p:grpSpPr>
       <p:sp>
         <p:nvSpPr>
-          <p:cNvPr id="31716338" name="Title 1"/>
+          <p:cNvPr id="691254341" name="Title 1"/>
           <p:cNvSpPr>
             <a:spLocks noGrp="1"/>
           </p:cNvSpPr>
@@ -2315,7 +2487,7 @@
       </p:sp>
       <p:sp>
         <p:nvSpPr>
-          <p:cNvPr id="346429412" name="Subtitle 2"/>
+          <p:cNvPr id="1997804607" name="Subtitle 2"/>
           <p:cNvSpPr>
             <a:spLocks noGrp="1"/>
           </p:cNvSpPr>
@@ -2437,7 +2609,7 @@
       </p:sp>
       <p:sp>
         <p:nvSpPr>
-          <p:cNvPr id="370720828" name="Date Placeholder 3"/>
+          <p:cNvPr id="1687332723" name="Date Placeholder 3"/>
           <p:cNvSpPr>
             <a:spLocks noGrp="1"/>
           </p:cNvSpPr>
@@ -2467,7 +2639,7 @@
       </p:sp>
       <p:sp>
         <p:nvSpPr>
-          <p:cNvPr id="636108612" name="Footer Placeholder 4"/>
+          <p:cNvPr id="1928228741" name="Footer Placeholder 4"/>
           <p:cNvSpPr>
             <a:spLocks noGrp="1"/>
           </p:cNvSpPr>
@@ -2493,7 +2665,7 @@
       </p:sp>
       <p:sp>
         <p:nvSpPr>
-          <p:cNvPr id="1863992918" name="Slide Number Placeholder 5"/>
+          <p:cNvPr id="87573722" name="Slide Number Placeholder 5"/>
           <p:cNvSpPr>
             <a:spLocks noGrp="1"/>
           </p:cNvSpPr>
@@ -2548,7 +2720,7 @@
       </p:grpSpPr>
       <p:sp>
         <p:nvSpPr>
-          <p:cNvPr id="500437645" name="Title 1"/>
+          <p:cNvPr id="1299089336" name="Title 1"/>
           <p:cNvSpPr>
             <a:spLocks noGrp="1"/>
           </p:cNvSpPr>
@@ -2574,7 +2746,7 @@
       </p:sp>
       <p:sp>
         <p:nvSpPr>
-          <p:cNvPr id="1500888692" name="Vertical Text Placeholder 2"/>
+          <p:cNvPr id="448840963" name="Vertical Text Placeholder 2"/>
           <p:cNvSpPr>
             <a:spLocks noGrp="1"/>
           </p:cNvSpPr>
@@ -2640,7 +2812,7 @@
       </p:sp>
       <p:sp>
         <p:nvSpPr>
-          <p:cNvPr id="1177923724" name="Date Placeholder 3"/>
+          <p:cNvPr id="563894931" name="Date Placeholder 3"/>
           <p:cNvSpPr>
             <a:spLocks noGrp="1"/>
           </p:cNvSpPr>
@@ -2670,7 +2842,7 @@
       </p:sp>
       <p:sp>
         <p:nvSpPr>
-          <p:cNvPr id="1507220532" name="Footer Placeholder 4"/>
+          <p:cNvPr id="1324333919" name="Footer Placeholder 4"/>
           <p:cNvSpPr>
             <a:spLocks noGrp="1"/>
           </p:cNvSpPr>
@@ -2696,7 +2868,7 @@
       </p:sp>
       <p:sp>
         <p:nvSpPr>
-          <p:cNvPr id="1540639176" name="Slide Number Placeholder 5"/>
+          <p:cNvPr id="1031182843" name="Slide Number Placeholder 5"/>
           <p:cNvSpPr>
             <a:spLocks noGrp="1"/>
           </p:cNvSpPr>
@@ -2751,7 +2923,7 @@
       </p:grpSpPr>
       <p:sp>
         <p:nvSpPr>
-          <p:cNvPr id="884238468" name="Vertical Title 1"/>
+          <p:cNvPr id="627757850" name="Vertical Title 1"/>
           <p:cNvSpPr>
             <a:spLocks noGrp="1"/>
           </p:cNvSpPr>
@@ -2782,7 +2954,7 @@
       </p:sp>
       <p:sp>
         <p:nvSpPr>
-          <p:cNvPr id="1162855597" name="Vertical Text Placeholder 2"/>
+          <p:cNvPr id="2126158116" name="Vertical Text Placeholder 2"/>
           <p:cNvSpPr>
             <a:spLocks noGrp="1"/>
           </p:cNvSpPr>
@@ -2853,7 +3025,7 @@
       </p:sp>
       <p:sp>
         <p:nvSpPr>
-          <p:cNvPr id="656955744" name="Date Placeholder 3"/>
+          <p:cNvPr id="1442854132" name="Date Placeholder 3"/>
           <p:cNvSpPr>
             <a:spLocks noGrp="1"/>
           </p:cNvSpPr>
@@ -2883,7 +3055,7 @@
       </p:sp>
       <p:sp>
         <p:nvSpPr>
-          <p:cNvPr id="967099811" name="Footer Placeholder 4"/>
+          <p:cNvPr id="563620169" name="Footer Placeholder 4"/>
           <p:cNvSpPr>
             <a:spLocks noGrp="1"/>
           </p:cNvSpPr>
@@ -2909,7 +3081,7 @@
       </p:sp>
       <p:sp>
         <p:nvSpPr>
-          <p:cNvPr id="717875463" name="Slide Number Placeholder 5"/>
+          <p:cNvPr id="1952661588" name="Slide Number Placeholder 5"/>
           <p:cNvSpPr>
             <a:spLocks noGrp="1"/>
           </p:cNvSpPr>
@@ -2964,7 +3136,7 @@
       </p:grpSpPr>
       <p:sp>
         <p:nvSpPr>
-          <p:cNvPr id="591121561" name="Title 1"/>
+          <p:cNvPr id="1179140651" name="Title 1"/>
           <p:cNvSpPr>
             <a:spLocks noGrp="1"/>
           </p:cNvSpPr>
@@ -2990,7 +3162,7 @@
       </p:sp>
       <p:sp>
         <p:nvSpPr>
-          <p:cNvPr id="1054768776" name="Content Placeholder 2"/>
+          <p:cNvPr id="286502878" name="Content Placeholder 2"/>
           <p:cNvSpPr>
             <a:spLocks noGrp="1"/>
           </p:cNvSpPr>
@@ -3056,7 +3228,7 @@
       </p:sp>
       <p:sp>
         <p:nvSpPr>
-          <p:cNvPr id="1596606058" name="Date Placeholder 3"/>
+          <p:cNvPr id="1972191647" name="Date Placeholder 3"/>
           <p:cNvSpPr>
             <a:spLocks noGrp="1"/>
           </p:cNvSpPr>
@@ -3086,7 +3258,7 @@
       </p:sp>
       <p:sp>
         <p:nvSpPr>
-          <p:cNvPr id="1598281155" name="Footer Placeholder 4"/>
+          <p:cNvPr id="1626292059" name="Footer Placeholder 4"/>
           <p:cNvSpPr>
             <a:spLocks noGrp="1"/>
           </p:cNvSpPr>
@@ -3112,7 +3284,7 @@
       </p:sp>
       <p:sp>
         <p:nvSpPr>
-          <p:cNvPr id="1177065792" name="Slide Number Placeholder 5"/>
+          <p:cNvPr id="1147600111" name="Slide Number Placeholder 5"/>
           <p:cNvSpPr>
             <a:spLocks noGrp="1"/>
           </p:cNvSpPr>
@@ -3167,7 +3339,7 @@
       </p:grpSpPr>
       <p:sp>
         <p:nvSpPr>
-          <p:cNvPr id="1596671848" name="Title 1"/>
+          <p:cNvPr id="1375723444" name="Title 1"/>
           <p:cNvSpPr>
             <a:spLocks noGrp="1"/>
           </p:cNvSpPr>
@@ -3202,7 +3374,7 @@
       </p:sp>
       <p:sp>
         <p:nvSpPr>
-          <p:cNvPr id="1812618963" name="Text Placeholder 2"/>
+          <p:cNvPr id="638373631" name="Text Placeholder 2"/>
           <p:cNvSpPr>
             <a:spLocks noGrp="1"/>
           </p:cNvSpPr>
@@ -3324,7 +3496,7 @@
       </p:sp>
       <p:sp>
         <p:nvSpPr>
-          <p:cNvPr id="1148873338" name="Date Placeholder 3"/>
+          <p:cNvPr id="415766037" name="Date Placeholder 3"/>
           <p:cNvSpPr>
             <a:spLocks noGrp="1"/>
           </p:cNvSpPr>
@@ -3354,7 +3526,7 @@
       </p:sp>
       <p:sp>
         <p:nvSpPr>
-          <p:cNvPr id="659904610" name="Footer Placeholder 4"/>
+          <p:cNvPr id="1606621316" name="Footer Placeholder 4"/>
           <p:cNvSpPr>
             <a:spLocks noGrp="1"/>
           </p:cNvSpPr>
@@ -3380,7 +3552,7 @@
       </p:sp>
       <p:sp>
         <p:nvSpPr>
-          <p:cNvPr id="1878086987" name="Slide Number Placeholder 5"/>
+          <p:cNvPr id="871349094" name="Slide Number Placeholder 5"/>
           <p:cNvSpPr>
             <a:spLocks noGrp="1"/>
           </p:cNvSpPr>
@@ -3435,7 +3607,7 @@
       </p:grpSpPr>
       <p:sp>
         <p:nvSpPr>
-          <p:cNvPr id="1631823189" name="Title 1"/>
+          <p:cNvPr id="1227755228" name="Title 1"/>
           <p:cNvSpPr>
             <a:spLocks noGrp="1"/>
           </p:cNvSpPr>
@@ -3461,7 +3633,7 @@
       </p:sp>
       <p:sp>
         <p:nvSpPr>
-          <p:cNvPr id="2134974967" name="Content Placeholder 2"/>
+          <p:cNvPr id="1720027980" name="Content Placeholder 2"/>
           <p:cNvSpPr>
             <a:spLocks noGrp="1"/>
           </p:cNvSpPr>
@@ -3560,7 +3732,7 @@
       </p:sp>
       <p:sp>
         <p:nvSpPr>
-          <p:cNvPr id="280639483" name="Content Placeholder 3"/>
+          <p:cNvPr id="1953177368" name="Content Placeholder 3"/>
           <p:cNvSpPr>
             <a:spLocks noGrp="1"/>
           </p:cNvSpPr>
@@ -3659,7 +3831,7 @@
       </p:sp>
       <p:sp>
         <p:nvSpPr>
-          <p:cNvPr id="889644288" name="Date Placeholder 3"/>
+          <p:cNvPr id="1136239872" name="Date Placeholder 3"/>
           <p:cNvSpPr>
             <a:spLocks noGrp="1"/>
           </p:cNvSpPr>
@@ -3689,7 +3861,7 @@
       </p:sp>
       <p:sp>
         <p:nvSpPr>
-          <p:cNvPr id="1316900177" name="Footer Placeholder 4"/>
+          <p:cNvPr id="951401671" name="Footer Placeholder 4"/>
           <p:cNvSpPr>
             <a:spLocks noGrp="1"/>
           </p:cNvSpPr>
@@ -3715,7 +3887,7 @@
       </p:sp>
       <p:sp>
         <p:nvSpPr>
-          <p:cNvPr id="394914849" name="Slide Number Placeholder 5"/>
+          <p:cNvPr id="752072257" name="Slide Number Placeholder 5"/>
           <p:cNvSpPr>
             <a:spLocks noGrp="1"/>
           </p:cNvSpPr>
@@ -3770,7 +3942,7 @@
       </p:grpSpPr>
       <p:sp>
         <p:nvSpPr>
-          <p:cNvPr id="580326044" name="Title 1"/>
+          <p:cNvPr id="683869650" name="Title 1"/>
           <p:cNvSpPr>
             <a:spLocks noGrp="1"/>
           </p:cNvSpPr>
@@ -3805,7 +3977,7 @@
       </p:sp>
       <p:sp>
         <p:nvSpPr>
-          <p:cNvPr id="1014753356" name="Content Placeholder 3"/>
+          <p:cNvPr id="556984521" name="Content Placeholder 3"/>
           <p:cNvSpPr>
             <a:spLocks noGrp="1"/>
           </p:cNvSpPr>
@@ -3904,7 +4076,7 @@
       </p:sp>
       <p:sp>
         <p:nvSpPr>
-          <p:cNvPr id="264845188" name="Content Placeholder 5"/>
+          <p:cNvPr id="1138301188" name="Content Placeholder 5"/>
           <p:cNvSpPr>
             <a:spLocks noGrp="1"/>
           </p:cNvSpPr>
@@ -4003,7 +4175,7 @@
       </p:sp>
       <p:sp>
         <p:nvSpPr>
-          <p:cNvPr id="1981361472" name="Date Placeholder 3"/>
+          <p:cNvPr id="447952736" name="Date Placeholder 3"/>
           <p:cNvSpPr>
             <a:spLocks noGrp="1"/>
           </p:cNvSpPr>
@@ -4033,7 +4205,7 @@
       </p:sp>
       <p:sp>
         <p:nvSpPr>
-          <p:cNvPr id="1815502911" name="Footer Placeholder 4"/>
+          <p:cNvPr id="551249613" name="Footer Placeholder 4"/>
           <p:cNvSpPr>
             <a:spLocks noGrp="1"/>
           </p:cNvSpPr>
@@ -4059,7 +4231,7 @@
       </p:sp>
       <p:sp>
         <p:nvSpPr>
-          <p:cNvPr id="1026439337" name="Slide Number Placeholder 5"/>
+          <p:cNvPr id="1250751750" name="Slide Number Placeholder 5"/>
           <p:cNvSpPr>
             <a:spLocks noGrp="1"/>
           </p:cNvSpPr>
@@ -4114,7 +4286,7 @@
       </p:grpSpPr>
       <p:sp>
         <p:nvSpPr>
-          <p:cNvPr id="205317624" name="Title 1"/>
+          <p:cNvPr id="1642730919" name="Title 1"/>
           <p:cNvSpPr>
             <a:spLocks noGrp="1"/>
           </p:cNvSpPr>
@@ -4140,7 +4312,7 @@
       </p:sp>
       <p:sp>
         <p:nvSpPr>
-          <p:cNvPr id="1775363380" name="Date Placeholder 3"/>
+          <p:cNvPr id="231360069" name="Date Placeholder 3"/>
           <p:cNvSpPr>
             <a:spLocks noGrp="1"/>
           </p:cNvSpPr>
@@ -4170,7 +4342,7 @@
       </p:sp>
       <p:sp>
         <p:nvSpPr>
-          <p:cNvPr id="1494853450" name="Footer Placeholder 4"/>
+          <p:cNvPr id="129291895" name="Footer Placeholder 4"/>
           <p:cNvSpPr>
             <a:spLocks noGrp="1"/>
           </p:cNvSpPr>
@@ -4196,7 +4368,7 @@
       </p:sp>
       <p:sp>
         <p:nvSpPr>
-          <p:cNvPr id="444219686" name="Slide Number Placeholder 5"/>
+          <p:cNvPr id="1902318624" name="Slide Number Placeholder 5"/>
           <p:cNvSpPr>
             <a:spLocks noGrp="1"/>
           </p:cNvSpPr>
@@ -4251,7 +4423,7 @@
       </p:grpSpPr>
       <p:sp>
         <p:nvSpPr>
-          <p:cNvPr id="495850221" name="Date Placeholder 3"/>
+          <p:cNvPr id="1341980739" name="Date Placeholder 3"/>
           <p:cNvSpPr>
             <a:spLocks noGrp="1"/>
           </p:cNvSpPr>
@@ -4281,7 +4453,7 @@
       </p:sp>
       <p:sp>
         <p:nvSpPr>
-          <p:cNvPr id="225868858" name="Footer Placeholder 4"/>
+          <p:cNvPr id="1210741766" name="Footer Placeholder 4"/>
           <p:cNvSpPr>
             <a:spLocks noGrp="1"/>
           </p:cNvSpPr>
@@ -4307,7 +4479,7 @@
       </p:sp>
       <p:sp>
         <p:nvSpPr>
-          <p:cNvPr id="1169583197" name="Slide Number Placeholder 5"/>
+          <p:cNvPr id="1571412367" name="Slide Number Placeholder 5"/>
           <p:cNvSpPr>
             <a:spLocks noGrp="1"/>
           </p:cNvSpPr>
@@ -4362,7 +4534,7 @@
       </p:grpSpPr>
       <p:sp>
         <p:nvSpPr>
-          <p:cNvPr id="806689108" name="Title 1"/>
+          <p:cNvPr id="830154775" name="Title 1"/>
           <p:cNvSpPr>
             <a:spLocks noGrp="1"/>
           </p:cNvSpPr>
@@ -4397,7 +4569,7 @@
       </p:sp>
       <p:sp>
         <p:nvSpPr>
-          <p:cNvPr id="1807195389" name="Content Placeholder 2"/>
+          <p:cNvPr id="2091469693" name="Content Placeholder 2"/>
           <p:cNvSpPr>
             <a:spLocks noGrp="1"/>
           </p:cNvSpPr>
@@ -4496,7 +4668,7 @@
       </p:sp>
       <p:sp>
         <p:nvSpPr>
-          <p:cNvPr id="801968368" name="Text Placeholder 3"/>
+          <p:cNvPr id="1840290932" name="Text Placeholder 3"/>
           <p:cNvSpPr>
             <a:spLocks noGrp="1"/>
           </p:cNvSpPr>
@@ -4564,7 +4736,7 @@
       </p:sp>
       <p:sp>
         <p:nvSpPr>
-          <p:cNvPr id="650500095" name="Date Placeholder 3"/>
+          <p:cNvPr id="1949260978" name="Date Placeholder 3"/>
           <p:cNvSpPr>
             <a:spLocks noGrp="1"/>
           </p:cNvSpPr>
@@ -4594,7 +4766,7 @@
       </p:sp>
       <p:sp>
         <p:nvSpPr>
-          <p:cNvPr id="709070591" name="Footer Placeholder 4"/>
+          <p:cNvPr id="700008982" name="Footer Placeholder 4"/>
           <p:cNvSpPr>
             <a:spLocks noGrp="1"/>
           </p:cNvSpPr>
@@ -4620,7 +4792,7 @@
       </p:sp>
       <p:sp>
         <p:nvSpPr>
-          <p:cNvPr id="528728893" name="Slide Number Placeholder 5"/>
+          <p:cNvPr id="297001572" name="Slide Number Placeholder 5"/>
           <p:cNvSpPr>
             <a:spLocks noGrp="1"/>
           </p:cNvSpPr>
@@ -4675,7 +4847,7 @@
       </p:grpSpPr>
       <p:sp>
         <p:nvSpPr>
-          <p:cNvPr id="676026455" name="Title 1"/>
+          <p:cNvPr id="1162912090" name="Title 1"/>
           <p:cNvSpPr>
             <a:spLocks noGrp="1"/>
           </p:cNvSpPr>
@@ -4710,7 +4882,7 @@
       </p:sp>
       <p:sp>
         <p:nvSpPr>
-          <p:cNvPr id="2010092395" name="Picture Placeholder 2"/>
+          <p:cNvPr id="256416970" name="Picture Placeholder 2"/>
           <p:cNvSpPr>
             <a:spLocks noGrp="1"/>
           </p:cNvSpPr>
@@ -4780,7 +4952,7 @@
       </p:sp>
       <p:sp>
         <p:nvSpPr>
-          <p:cNvPr id="1977640156" name="Text Placeholder 3"/>
+          <p:cNvPr id="411379447" name="Text Placeholder 3"/>
           <p:cNvSpPr>
             <a:spLocks noGrp="1"/>
           </p:cNvSpPr>
@@ -4848,7 +5020,7 @@
       </p:sp>
       <p:sp>
         <p:nvSpPr>
-          <p:cNvPr id="1768643283" name="Date Placeholder 3"/>
+          <p:cNvPr id="898324880" name="Date Placeholder 3"/>
           <p:cNvSpPr>
             <a:spLocks noGrp="1"/>
           </p:cNvSpPr>
@@ -4878,7 +5050,7 @@
       </p:sp>
       <p:sp>
         <p:nvSpPr>
-          <p:cNvPr id="607390166" name="Footer Placeholder 4"/>
+          <p:cNvPr id="1027130210" name="Footer Placeholder 4"/>
           <p:cNvSpPr>
             <a:spLocks noGrp="1"/>
           </p:cNvSpPr>
@@ -4904,7 +5076,7 @@
       </p:sp>
       <p:sp>
         <p:nvSpPr>
-          <p:cNvPr id="518740997" name="Slide Number Placeholder 5"/>
+          <p:cNvPr id="613570614" name="Slide Number Placeholder 5"/>
           <p:cNvSpPr>
             <a:spLocks noGrp="1"/>
           </p:cNvSpPr>
@@ -4964,7 +5136,7 @@
       </p:grpSpPr>
       <p:sp>
         <p:nvSpPr>
-          <p:cNvPr id="1861168026" name="Title Placeholder 1"/>
+          <p:cNvPr id="892680820" name="Title Placeholder 1"/>
           <p:cNvSpPr>
             <a:spLocks noGrp="1"/>
           </p:cNvSpPr>
@@ -5011,7 +5183,7 @@
       </p:sp>
       <p:sp>
         <p:nvSpPr>
-          <p:cNvPr id="1032950059" name="Text Placeholder 2"/>
+          <p:cNvPr id="2038184077" name="Text Placeholder 2"/>
           <p:cNvSpPr>
             <a:spLocks noGrp="1"/>
           </p:cNvSpPr>
@@ -5091,7 +5263,7 @@
       </p:sp>
       <p:sp>
         <p:nvSpPr>
-          <p:cNvPr id="1184202060" name="Date Placeholder 3"/>
+          <p:cNvPr id="788602699" name="Date Placeholder 3"/>
           <p:cNvSpPr>
             <a:spLocks noGrp="1"/>
           </p:cNvSpPr>
@@ -5144,7 +5316,7 @@
       </p:sp>
       <p:sp>
         <p:nvSpPr>
-          <p:cNvPr id="1939869976" name="Footer Placeholder 4"/>
+          <p:cNvPr id="937880206" name="Footer Placeholder 4"/>
           <p:cNvSpPr>
             <a:spLocks noGrp="1"/>
           </p:cNvSpPr>
@@ -5193,7 +5365,7 @@
       </p:sp>
       <p:sp>
         <p:nvSpPr>
-          <p:cNvPr id="1704483205" name="Slide Number Placeholder 5"/>
+          <p:cNvPr id="82671946" name="Slide Number Placeholder 5"/>
           <p:cNvSpPr>
             <a:spLocks noGrp="1"/>
           </p:cNvSpPr>
@@ -5246,7 +5418,7 @@
       </p:sp>
       <p:pic>
         <p:nvPicPr>
-          <p:cNvPr id="583155094" name="Picture 7"/>
+          <p:cNvPr id="2043255101" name="Picture 7"/>
           <p:cNvPicPr>
             <a:picLocks noChangeAspect="1"/>
           </p:cNvPicPr>
@@ -5691,7 +5863,7 @@
       </p:grpSpPr>
       <p:sp>
         <p:nvSpPr>
-          <p:cNvPr id="1081770968" name="Title 1"/>
+          <p:cNvPr id="1790559143" name="Title 1"/>
           <p:cNvSpPr>
             <a:spLocks noGrp="1"/>
           </p:cNvSpPr>
@@ -5721,7 +5893,7 @@
       </p:sp>
       <p:sp>
         <p:nvSpPr>
-          <p:cNvPr id="606012803" name="Subtitle 2"/>
+          <p:cNvPr id="1577902368" name="Subtitle 2"/>
           <p:cNvSpPr>
             <a:spLocks noGrp="1"/>
           </p:cNvSpPr>
@@ -5810,7 +5982,7 @@
       </p:grpSpPr>
       <p:sp>
         <p:nvSpPr>
-          <p:cNvPr id="1327372423" name="Title 1"/>
+          <p:cNvPr id="1580733906" name="Title 1"/>
           <p:cNvSpPr>
             <a:spLocks noGrp="1"/>
           </p:cNvSpPr>
@@ -5836,7 +6008,7 @@
       </p:sp>
       <p:sp>
         <p:nvSpPr>
-          <p:cNvPr id="213878838" name="Content Placeholder 2"/>
+          <p:cNvPr id="262684542" name="Content Placeholder 2"/>
           <p:cNvSpPr>
             <a:spLocks noGrp="1"/>
           </p:cNvSpPr>
@@ -5925,7 +6097,7 @@
       </p:sp>
       <p:sp>
         <p:nvSpPr>
-          <p:cNvPr id="1168698505" name="Content Placeholder 3"/>
+          <p:cNvPr id="1764020269" name="Content Placeholder 3"/>
           <p:cNvSpPr>
             <a:spLocks noGrp="1"/>
           </p:cNvSpPr>
@@ -6618,7 +6790,7 @@
       </p:grpSpPr>
       <p:sp>
         <p:nvSpPr>
-          <p:cNvPr id="451001379" name="Title 1"/>
+          <p:cNvPr id="1737601352" name="Title 1"/>
           <p:cNvSpPr>
             <a:spLocks noGrp="1"/>
           </p:cNvSpPr>
@@ -6644,7 +6816,7 @@
       </p:sp>
       <p:graphicFrame>
         <p:nvGraphicFramePr>
-          <p:cNvPr id="1840116022" name=""/>
+          <p:cNvPr id="367732118" name=""/>
           <p:cNvGraphicFramePr>
             <a:graphicFrameLocks xmlns:a="http://schemas.openxmlformats.org/drawingml/2006/main"/>
           </p:cNvGraphicFramePr>
@@ -6652,7 +6824,7 @@
             <p:ph sz="half" idx="1"/>
           </p:nvPr>
         </p:nvGraphicFramePr>
-        <p:xfrm>
+        <p:xfrm rot="0">
           <a:off x="457200" y="1258488"/>
           <a:ext cx="4038597" cy="1346088"/>
         </p:xfrm>
@@ -6988,7 +7160,7 @@
       </p:graphicFrame>
       <p:sp>
         <p:nvSpPr>
-          <p:cNvPr id="651738564" name="Content Placeholder 3"/>
+          <p:cNvPr id="450758956" name="Content Placeholder 3"/>
           <p:cNvSpPr>
             <a:spLocks noGrp="1"/>
           </p:cNvSpPr>
@@ -7648,13 +7820,13 @@
       </p:sp>
       <p:sp>
         <p:nvSpPr>
-          <p:cNvPr id="611171182" name=""/>
+          <p:cNvPr id="47968284" name=""/>
           <p:cNvSpPr txBox="1"/>
           <p:nvPr/>
         </p:nvSpPr>
         <p:spPr bwMode="auto">
           <a:xfrm rot="0" flipH="0" flipV="0">
-            <a:off x="451162" y="3263604"/>
+            <a:off x="451161" y="3263604"/>
             <a:ext cx="4072095" cy="366119"/>
           </a:xfrm>
           <a:prstGeom prst="rect">
@@ -7713,7 +7885,7 @@
       </p:grpSpPr>
       <p:graphicFrame>
         <p:nvGraphicFramePr>
-          <p:cNvPr id="1095798658" name=""/>
+          <p:cNvPr id="647198332" name=""/>
           <p:cNvGraphicFramePr>
             <a:graphicFrameLocks xmlns:a="http://schemas.openxmlformats.org/drawingml/2006/main"/>
           </p:cNvGraphicFramePr>
@@ -7721,7 +7893,7 @@
             <p:ph sz="half" idx="2"/>
           </p:nvPr>
         </p:nvGraphicFramePr>
-        <p:xfrm>
+        <p:xfrm rot="0">
           <a:off x="186069" y="1324942"/>
           <a:ext cx="8771860" cy="3578859"/>
         </p:xfrm>
@@ -9884,7 +10056,7 @@
       </p:graphicFrame>
       <p:sp>
         <p:nvSpPr>
-          <p:cNvPr id="1976136636" name="Title 1"/>
+          <p:cNvPr id="2027653609" name="Title 1"/>
           <p:cNvSpPr>
             <a:spLocks noGrp="1"/>
           </p:cNvSpPr>
@@ -9943,7 +10115,7 @@
       </p:grpSpPr>
       <p:graphicFrame>
         <p:nvGraphicFramePr>
-          <p:cNvPr id="171094280" name=""/>
+          <p:cNvPr id="1373739953" name=""/>
           <p:cNvGraphicFramePr>
             <a:graphicFrameLocks xmlns:a="http://schemas.openxmlformats.org/drawingml/2006/main"/>
           </p:cNvGraphicFramePr>
@@ -9951,7 +10123,7 @@
             <p:ph sz="half" idx="2"/>
           </p:nvPr>
         </p:nvGraphicFramePr>
-        <p:xfrm>
+        <p:xfrm rot="0">
           <a:off x="186069" y="1324942"/>
           <a:ext cx="8771860" cy="3578859"/>
         </p:xfrm>
@@ -12952,7 +13124,7 @@
       </p:graphicFrame>
       <p:sp>
         <p:nvSpPr>
-          <p:cNvPr id="1305787277" name="Title 1"/>
+          <p:cNvPr id="1380708877" name="Title 1"/>
           <p:cNvSpPr>
             <a:spLocks noGrp="1"/>
           </p:cNvSpPr>
@@ -13011,7 +13183,7 @@
       </p:grpSpPr>
       <p:sp>
         <p:nvSpPr>
-          <p:cNvPr id="746919868" name="Title 1"/>
+          <p:cNvPr id="173322098" name="Title 1"/>
           <p:cNvSpPr>
             <a:spLocks noGrp="1"/>
           </p:cNvSpPr>
@@ -13037,7 +13209,7 @@
       </p:sp>
       <p:sp>
         <p:nvSpPr>
-          <p:cNvPr id="1208051910" name="Content Placeholder 2"/>
+          <p:cNvPr id="140639976" name="Content Placeholder 2"/>
           <p:cNvSpPr>
             <a:spLocks noGrp="1"/>
           </p:cNvSpPr>
@@ -13131,7 +13303,7 @@
       </p:sp>
       <p:pic>
         <p:nvPicPr>
-          <p:cNvPr id="303769064" name=""/>
+          <p:cNvPr id="490136605" name=""/>
           <p:cNvPicPr>
             <a:picLocks noChangeAspect="1"/>
           </p:cNvPicPr>
@@ -13155,7 +13327,7 @@
       </p:pic>
       <p:pic>
         <p:nvPicPr>
-          <p:cNvPr id="743550303" name=""/>
+          <p:cNvPr id="1650845835" name=""/>
           <p:cNvPicPr>
             <a:picLocks noChangeAspect="1"/>
           </p:cNvPicPr>
@@ -13208,9 +13380,64 @@
           <a:chExt cx="0" cy="0"/>
         </a:xfrm>
       </p:grpSpPr>
-      <p:sp>
-        <p:nvSpPr>
-          <p:cNvPr id="159874346" name="Title 1"/>
+      <p:pic>
+        <p:nvPicPr>
+          <p:cNvPr id="938858732" name=""/>
+          <p:cNvPicPr>
+            <a:picLocks noChangeAspect="1"/>
+          </p:cNvPicPr>
+          <p:nvPr/>
+        </p:nvPicPr>
+        <p:blipFill rotWithShape="1">
+          <a:blip r:embed="rId3"/>
+          <a:stretch/>
+        </p:blipFill>
+        <p:spPr bwMode="auto">
+          <a:xfrm>
+            <a:off x="1956631" y="0"/>
+            <a:ext cx="5230737" cy="5143500"/>
+          </a:xfrm>
+          <a:prstGeom prst="rect">
+            <a:avLst/>
+          </a:prstGeom>
+        </p:spPr>
+      </p:pic>
+    </p:spTree>
+  </p:cSld>
+  <p:clrMapOvr>
+    <a:masterClrMapping/>
+  </p:clrMapOvr>
+  <mc:AlternateContent xmlns:mc="http://schemas.openxmlformats.org/markup-compatibility/2006">
+    <mc:Choice xmlns:p159="http://schemas.microsoft.com/office/powerpoint/2015/09/main" xmlns:p14="http://schemas.microsoft.com/office/powerpoint/2010/main" Requires="p159">
+      <p:transition p14:dur="2000" advClick="1"/>
+    </mc:Choice>
+    <mc:Fallback>
+      <p:transition advClick="1"/>
+    </mc:Fallback>
+  </mc:AlternateContent>
+</p:sld>
+</file>
+
+<file path=ppt/slides/slide16.xml><?xml version="1.0" encoding="utf-8"?>
+<p:sld xmlns:a="http://schemas.openxmlformats.org/drawingml/2006/main" xmlns:r="http://schemas.openxmlformats.org/officeDocument/2006/relationships" xmlns:p="http://schemas.openxmlformats.org/presentationml/2006/main" xmlns:m="http://schemas.openxmlformats.org/officeDocument/2006/math" xmlns:w="http://schemas.openxmlformats.org/wordprocessingml/2006/main" xmlns:mc="http://schemas.openxmlformats.org/markup-compatibility/2006" showMasterPhAnim="0" showMasterSp="1" show="1">
+  <p:cSld name="">
+    <p:spTree>
+      <p:nvGrpSpPr>
+        <p:cNvPr id="1" name=""/>
+        <p:cNvGrpSpPr/>
+        <p:nvPr/>
+      </p:nvGrpSpPr>
+      <p:grpSpPr bwMode="auto">
+        <a:xfrm>
+          <a:off x="0" y="0"/>
+          <a:ext cx="0" cy="0"/>
+          <a:chOff x="0" y="0"/>
+          <a:chExt cx="0" cy="0"/>
+        </a:xfrm>
+      </p:grpSpPr>
+      <p:sp>
+        <p:nvSpPr>
+          <p:cNvPr id="727659548" name="Title 1"/>
           <p:cNvSpPr>
             <a:spLocks noGrp="1"/>
           </p:cNvSpPr>
@@ -13228,6 +13455,188 @@
             </a:pPr>
             <a:r>
               <a:rPr/>
+              <a:t>Can perceptron do regression?</a:t>
+            </a:r>
+            <a:endParaRPr/>
+          </a:p>
+        </p:txBody>
+      </p:sp>
+      <p:sp>
+        <p:nvSpPr>
+          <p:cNvPr id="768926640" name="Content Placeholder 2"/>
+          <p:cNvSpPr>
+            <a:spLocks noGrp="1"/>
+          </p:cNvSpPr>
+          <p:nvPr>
+            <p:ph sz="half" idx="1"/>
+          </p:nvPr>
+        </p:nvSpPr>
+        <p:spPr bwMode="auto">
+          <a:xfrm flipH="0" flipV="0">
+            <a:off x="457200" y="1258488"/>
+            <a:ext cx="4038597" cy="3336132"/>
+          </a:xfrm>
+        </p:spPr>
+        <p:txBody>
+          <a:bodyPr/>
+          <a:lstStyle>
+            <a:lvl1pPr>
+              <a:defRPr sz="2400"/>
+            </a:lvl1pPr>
+            <a:lvl2pPr>
+              <a:defRPr sz="2000"/>
+            </a:lvl2pPr>
+            <a:lvl3pPr>
+              <a:defRPr sz="1600"/>
+            </a:lvl3pPr>
+            <a:lvl4pPr>
+              <a:defRPr sz="1400"/>
+            </a:lvl4pPr>
+            <a:lvl5pPr>
+              <a:defRPr sz="1400"/>
+            </a:lvl5pPr>
+            <a:lvl6pPr>
+              <a:defRPr sz="1800"/>
+            </a:lvl6pPr>
+            <a:lvl7pPr>
+              <a:defRPr sz="1800"/>
+            </a:lvl7pPr>
+            <a:lvl8pPr>
+              <a:defRPr sz="1800"/>
+            </a:lvl8pPr>
+            <a:lvl9pPr>
+              <a:defRPr sz="1800"/>
+            </a:lvl9pPr>
+          </a:lstStyle>
+          <a:p>
+            <a:pPr>
+              <a:defRPr/>
+            </a:pPr>
+            <a:r>
+              <a:rPr/>
+              <a:t>Yes!</a:t>
+            </a:r>
+            <a:endParaRPr/>
+          </a:p>
+          <a:p>
+            <a:pPr>
+              <a:defRPr/>
+            </a:pPr>
+            <a:r>
+              <a:rPr/>
+              <a:t>Use activation function</a:t>
+            </a:r>
+            <a:endParaRPr/>
+          </a:p>
+          <a:p>
+            <a:pPr>
+              <a:defRPr/>
+            </a:pPr>
+            <a:r>
+              <a:rPr/>
+              <a:t>Scale inputs before putting in perceptron</a:t>
+            </a:r>
+            <a:endParaRPr/>
+          </a:p>
+          <a:p>
+            <a:pPr>
+              <a:defRPr/>
+            </a:pPr>
+            <a:r>
+              <a:rPr/>
+              <a:t>Use same scaling to output regression value</a:t>
+            </a:r>
+            <a:endParaRPr/>
+          </a:p>
+          <a:p>
+            <a:pPr>
+              <a:defRPr/>
+            </a:pPr>
+            <a:r>
+              <a:rPr/>
+              <a:t>Use MSE or other regression loss function</a:t>
+            </a:r>
+            <a:endParaRPr/>
+          </a:p>
+        </p:txBody>
+      </p:sp>
+      <p:pic>
+        <p:nvPicPr>
+          <p:cNvPr id="2010906079" name=""/>
+          <p:cNvPicPr>
+            <a:picLocks noChangeAspect="1"/>
+          </p:cNvPicPr>
+          <p:nvPr>
+            <p:ph sz="half" idx="2"/>
+          </p:nvPr>
+        </p:nvPicPr>
+        <p:blipFill rotWithShape="1">
+          <a:blip r:embed="rId3"/>
+          <a:stretch/>
+        </p:blipFill>
+        <p:spPr bwMode="auto">
+          <a:xfrm rot="0" flipH="0" flipV="0">
+            <a:off x="5015943" y="1258489"/>
+            <a:ext cx="3306979" cy="3696953"/>
+          </a:xfrm>
+          <a:prstGeom prst="rect">
+            <a:avLst/>
+          </a:prstGeom>
+        </p:spPr>
+      </p:pic>
+    </p:spTree>
+  </p:cSld>
+  <p:clrMapOvr>
+    <a:masterClrMapping/>
+  </p:clrMapOvr>
+  <mc:AlternateContent xmlns:mc="http://schemas.openxmlformats.org/markup-compatibility/2006">
+    <mc:Choice xmlns:p159="http://schemas.microsoft.com/office/powerpoint/2015/09/main" xmlns:p14="http://schemas.microsoft.com/office/powerpoint/2010/main" Requires="p159">
+      <p:transition p14:dur="2000" advClick="1"/>
+    </mc:Choice>
+    <mc:Fallback>
+      <p:transition advClick="1"/>
+    </mc:Fallback>
+  </mc:AlternateContent>
+</p:sld>
+</file>
+
+<file path=ppt/slides/slide17.xml><?xml version="1.0" encoding="utf-8"?>
+<p:sld xmlns:a="http://schemas.openxmlformats.org/drawingml/2006/main" xmlns:r="http://schemas.openxmlformats.org/officeDocument/2006/relationships" xmlns:p="http://schemas.openxmlformats.org/presentationml/2006/main" xmlns:m="http://schemas.openxmlformats.org/officeDocument/2006/math" xmlns:w="http://schemas.openxmlformats.org/wordprocessingml/2006/main" xmlns:mc="http://schemas.openxmlformats.org/markup-compatibility/2006" showMasterPhAnim="0" showMasterSp="1" show="1">
+  <p:cSld name="">
+    <p:spTree>
+      <p:nvGrpSpPr>
+        <p:cNvPr id="1" name=""/>
+        <p:cNvGrpSpPr/>
+        <p:nvPr/>
+      </p:nvGrpSpPr>
+      <p:grpSpPr bwMode="auto">
+        <a:xfrm>
+          <a:off x="0" y="0"/>
+          <a:ext cx="0" cy="0"/>
+          <a:chOff x="0" y="0"/>
+          <a:chExt cx="0" cy="0"/>
+        </a:xfrm>
+      </p:grpSpPr>
+      <p:sp>
+        <p:nvSpPr>
+          <p:cNvPr id="281823100" name="Title 1"/>
+          <p:cNvSpPr>
+            <a:spLocks noGrp="1"/>
+          </p:cNvSpPr>
+          <p:nvPr>
+            <p:ph type="title"/>
+          </p:nvPr>
+        </p:nvSpPr>
+        <p:spPr bwMode="auto"/>
+        <p:txBody>
+          <a:bodyPr/>
+          <a:lstStyle/>
+          <a:p>
+            <a:pPr>
+              <a:defRPr/>
+            </a:pPr>
+            <a:r>
+              <a:rPr/>
               <a:t>Multi-Layer Perceptron (MLP)</a:t>
             </a:r>
             <a:endParaRPr/>
@@ -13236,7 +13645,7 @@
       </p:sp>
       <p:sp>
         <p:nvSpPr>
-          <p:cNvPr id="1515498286" name="Text Placeholder 2"/>
+          <p:cNvPr id="93569940" name="Text Placeholder 2"/>
           <p:cNvSpPr>
             <a:spLocks noGrp="1"/>
           </p:cNvSpPr>
@@ -13368,7 +13777,7 @@
 </p:sld>
 </file>
 
-<file path=ppt/slides/slide16.xml><?xml version="1.0" encoding="utf-8"?>
+<file path=ppt/slides/slide18.xml><?xml version="1.0" encoding="utf-8"?>
 <p:sld xmlns:a="http://schemas.openxmlformats.org/drawingml/2006/main" xmlns:r="http://schemas.openxmlformats.org/officeDocument/2006/relationships" xmlns:p="http://schemas.openxmlformats.org/presentationml/2006/main" xmlns:m="http://schemas.openxmlformats.org/officeDocument/2006/math" xmlns:w="http://schemas.openxmlformats.org/wordprocessingml/2006/main" xmlns:mc="http://schemas.openxmlformats.org/markup-compatibility/2006" showMasterPhAnim="0" showMasterSp="1" show="1">
   <p:cSld name="">
     <p:spTree>
@@ -13387,7 +13796,7 @@
       </p:grpSpPr>
       <p:sp>
         <p:nvSpPr>
-          <p:cNvPr id="880413663" name="Title 1"/>
+          <p:cNvPr id="1826400823" name="Title 1"/>
           <p:cNvSpPr>
             <a:spLocks noGrp="1"/>
           </p:cNvSpPr>
@@ -13413,7 +13822,7 @@
       </p:sp>
       <p:sp>
         <p:nvSpPr>
-          <p:cNvPr id="398104846" name="Content Placeholder 2"/>
+          <p:cNvPr id="1254621459" name="Content Placeholder 2"/>
           <p:cNvSpPr>
             <a:spLocks noGrp="1"/>
           </p:cNvSpPr>
@@ -13492,7 +13901,7 @@
       </p:sp>
       <p:pic>
         <p:nvPicPr>
-          <p:cNvPr id="755732782" name=""/>
+          <p:cNvPr id="913335904" name=""/>
           <p:cNvPicPr>
             <a:picLocks noChangeAspect="1"/>
           </p:cNvPicPr>
@@ -13506,8 +13915,8 @@
         </p:blipFill>
         <p:spPr bwMode="auto">
           <a:xfrm rot="0">
-            <a:off x="4648198" y="1654396"/>
-            <a:ext cx="4038597" cy="2544316"/>
+            <a:off x="4648197" y="1654396"/>
+            <a:ext cx="4038597" cy="2544315"/>
           </a:xfrm>
           <a:prstGeom prst="rect">
             <a:avLst/>
@@ -13530,7 +13939,7 @@
 </p:sld>
 </file>
 
-<file path=ppt/slides/slide17.xml><?xml version="1.0" encoding="utf-8"?>
+<file path=ppt/slides/slide19.xml><?xml version="1.0" encoding="utf-8"?>
 <p:sld xmlns:a="http://schemas.openxmlformats.org/drawingml/2006/main" xmlns:r="http://schemas.openxmlformats.org/officeDocument/2006/relationships" xmlns:p="http://schemas.openxmlformats.org/presentationml/2006/main" xmlns:m="http://schemas.openxmlformats.org/officeDocument/2006/math" xmlns:w="http://schemas.openxmlformats.org/wordprocessingml/2006/main" xmlns:mc="http://schemas.openxmlformats.org/markup-compatibility/2006" showMasterPhAnim="0" showMasterSp="1" show="1">
   <p:cSld name="">
     <p:spTree>
@@ -13549,7 +13958,7 @@
       </p:grpSpPr>
       <p:sp>
         <p:nvSpPr>
-          <p:cNvPr id="1037540210" name="Title 1"/>
+          <p:cNvPr id="802306738" name="Title 1"/>
           <p:cNvSpPr>
             <a:spLocks noGrp="1"/>
           </p:cNvSpPr>
@@ -13575,7 +13984,7 @@
       </p:sp>
       <p:sp>
         <p:nvSpPr>
-          <p:cNvPr id="1639796033" name="Content Placeholder 2"/>
+          <p:cNvPr id="1043463698" name="Content Placeholder 2"/>
           <p:cNvSpPr>
             <a:spLocks noGrp="1"/>
           </p:cNvSpPr>
@@ -13635,7 +14044,7 @@
 </p:sld>
 </file>
 
-<file path=ppt/slides/slide18.xml><?xml version="1.0" encoding="utf-8"?>
+<file path=ppt/slides/slide2.xml><?xml version="1.0" encoding="utf-8"?>
 <p:sld xmlns:a="http://schemas.openxmlformats.org/drawingml/2006/main" xmlns:r="http://schemas.openxmlformats.org/officeDocument/2006/relationships" xmlns:p="http://schemas.openxmlformats.org/presentationml/2006/main" xmlns:m="http://schemas.openxmlformats.org/officeDocument/2006/math" xmlns:w="http://schemas.openxmlformats.org/wordprocessingml/2006/main" xmlns:mc="http://schemas.openxmlformats.org/markup-compatibility/2006" showMasterPhAnim="0" showMasterSp="1" show="1">
   <p:cSld name="">
     <p:spTree>
@@ -13654,7 +14063,7 @@
       </p:grpSpPr>
       <p:sp>
         <p:nvSpPr>
-          <p:cNvPr id="70481415" name="Title 1"/>
+          <p:cNvPr id="1309344063" name="Title 1"/>
           <p:cNvSpPr>
             <a:spLocks noGrp="1"/>
           </p:cNvSpPr>
@@ -13672,6 +14081,141 @@
             </a:pPr>
             <a:r>
               <a:rPr/>
+              <a:t>Outline</a:t>
+            </a:r>
+            <a:endParaRPr/>
+          </a:p>
+        </p:txBody>
+      </p:sp>
+      <p:sp>
+        <p:nvSpPr>
+          <p:cNvPr id="1929797405" name="Content Placeholder 2"/>
+          <p:cNvSpPr>
+            <a:spLocks noGrp="1"/>
+          </p:cNvSpPr>
+          <p:nvPr>
+            <p:ph idx="1"/>
+          </p:nvPr>
+        </p:nvSpPr>
+        <p:spPr bwMode="auto"/>
+        <p:txBody>
+          <a:bodyPr/>
+          <a:lstStyle/>
+          <a:p>
+            <a:pPr>
+              <a:defRPr/>
+            </a:pPr>
+            <a:r>
+              <a:rPr/>
+              <a:t>Neural Networks</a:t>
+            </a:r>
+            <a:endParaRPr/>
+          </a:p>
+          <a:p>
+            <a:pPr lvl="1">
+              <a:defRPr/>
+            </a:pPr>
+            <a:r>
+              <a:rPr/>
+              <a:t>Perceptron</a:t>
+            </a:r>
+            <a:endParaRPr/>
+          </a:p>
+          <a:p>
+            <a:pPr lvl="1">
+              <a:defRPr/>
+            </a:pPr>
+            <a:r>
+              <a:rPr/>
+              <a:t>Multi-Layer Perceptron</a:t>
+            </a:r>
+            <a:endParaRPr/>
+          </a:p>
+          <a:p>
+            <a:pPr lvl="1">
+              <a:defRPr/>
+            </a:pPr>
+            <a:r>
+              <a:rPr/>
+              <a:t>Recursive Neural Networks (RNNs)</a:t>
+            </a:r>
+            <a:endParaRPr/>
+          </a:p>
+          <a:p>
+            <a:pPr lvl="1">
+              <a:defRPr/>
+            </a:pPr>
+            <a:r>
+              <a:rPr/>
+              <a:t>NeuralODE</a:t>
+            </a:r>
+            <a:endParaRPr/>
+          </a:p>
+          <a:p>
+            <a:pPr lvl="0">
+              <a:defRPr/>
+            </a:pPr>
+            <a:r>
+              <a:rPr/>
+              <a:t>Gathering Data</a:t>
+            </a:r>
+            <a:endParaRPr/>
+          </a:p>
+        </p:txBody>
+      </p:sp>
+    </p:spTree>
+  </p:cSld>
+  <p:clrMapOvr>
+    <a:masterClrMapping/>
+  </p:clrMapOvr>
+  <mc:AlternateContent xmlns:mc="http://schemas.openxmlformats.org/markup-compatibility/2006">
+    <mc:Choice xmlns:p159="http://schemas.microsoft.com/office/powerpoint/2015/09/main" xmlns:p14="http://schemas.microsoft.com/office/powerpoint/2010/main" Requires="p159">
+      <p:transition p14:dur="2000" advClick="1"/>
+    </mc:Choice>
+    <mc:Fallback>
+      <p:transition advClick="1"/>
+    </mc:Fallback>
+  </mc:AlternateContent>
+</p:sld>
+</file>
+
+<file path=ppt/slides/slide20.xml><?xml version="1.0" encoding="utf-8"?>
+<p:sld xmlns:a="http://schemas.openxmlformats.org/drawingml/2006/main" xmlns:r="http://schemas.openxmlformats.org/officeDocument/2006/relationships" xmlns:p="http://schemas.openxmlformats.org/presentationml/2006/main" xmlns:m="http://schemas.openxmlformats.org/officeDocument/2006/math" xmlns:w="http://schemas.openxmlformats.org/wordprocessingml/2006/main" xmlns:mc="http://schemas.openxmlformats.org/markup-compatibility/2006" showMasterPhAnim="0" showMasterSp="1" show="1">
+  <p:cSld name="">
+    <p:spTree>
+      <p:nvGrpSpPr>
+        <p:cNvPr id="1" name=""/>
+        <p:cNvGrpSpPr/>
+        <p:nvPr/>
+      </p:nvGrpSpPr>
+      <p:grpSpPr bwMode="auto">
+        <a:xfrm>
+          <a:off x="0" y="0"/>
+          <a:ext cx="0" cy="0"/>
+          <a:chOff x="0" y="0"/>
+          <a:chExt cx="0" cy="0"/>
+        </a:xfrm>
+      </p:grpSpPr>
+      <p:sp>
+        <p:nvSpPr>
+          <p:cNvPr id="1930461397" name="Title 1"/>
+          <p:cNvSpPr>
+            <a:spLocks noGrp="1"/>
+          </p:cNvSpPr>
+          <p:nvPr>
+            <p:ph type="title"/>
+          </p:nvPr>
+        </p:nvSpPr>
+        <p:spPr bwMode="auto"/>
+        <p:txBody>
+          <a:bodyPr/>
+          <a:lstStyle/>
+          <a:p>
+            <a:pPr>
+              <a:defRPr/>
+            </a:pPr>
+            <a:r>
+              <a:rPr/>
               <a:t>Backpropagation</a:t>
             </a:r>
             <a:endParaRPr/>
@@ -13680,7 +14224,7 @@
       </p:sp>
       <p:sp>
         <p:nvSpPr>
-          <p:cNvPr id="2098487888" name="Content Placeholder 2"/>
+          <p:cNvPr id="232134056" name="Content Placeholder 2"/>
           <p:cNvSpPr>
             <a:spLocks noGrp="1"/>
           </p:cNvSpPr>
@@ -13745,7 +14289,7 @@
       </p:sp>
       <p:sp>
         <p:nvSpPr>
-          <p:cNvPr id="1473851846" name="Content Placeholder 3"/>
+          <p:cNvPr id="2135131290" name="Content Placeholder 3"/>
           <p:cNvSpPr>
             <a:spLocks noGrp="1"/>
           </p:cNvSpPr>
@@ -13755,7 +14299,7 @@
         </p:nvSpPr>
         <p:spPr bwMode="auto">
           <a:xfrm flipH="0" flipV="0">
-            <a:off x="4648198" y="1258488"/>
+            <a:off x="4648197" y="1258488"/>
             <a:ext cx="4038597" cy="3336132"/>
           </a:xfrm>
         </p:spPr>
@@ -13988,7 +14532,7 @@
 </p:sld>
 </file>
 
-<file path=ppt/slides/slide19.xml><?xml version="1.0" encoding="utf-8"?>
+<file path=ppt/slides/slide21.xml><?xml version="1.0" encoding="utf-8"?>
 <p:sld xmlns:a="http://schemas.openxmlformats.org/drawingml/2006/main" xmlns:r="http://schemas.openxmlformats.org/officeDocument/2006/relationships" xmlns:p="http://schemas.openxmlformats.org/presentationml/2006/main" xmlns:m="http://schemas.openxmlformats.org/officeDocument/2006/math" xmlns:w="http://schemas.openxmlformats.org/wordprocessingml/2006/main" xmlns:mc="http://schemas.openxmlformats.org/markup-compatibility/2006" showMasterPhAnim="0" showMasterSp="1" show="1">
   <p:cSld name="">
     <p:spTree>
@@ -14007,7 +14551,7 @@
       </p:grpSpPr>
       <p:sp>
         <p:nvSpPr>
-          <p:cNvPr id="768819920" name="Title 1"/>
+          <p:cNvPr id="454503127" name="Title 1"/>
           <p:cNvSpPr>
             <a:spLocks noGrp="1"/>
           </p:cNvSpPr>
@@ -14042,7 +14586,7 @@
       </p:sp>
       <p:sp>
         <p:nvSpPr>
-          <p:cNvPr id="1349848923" name="Text Placeholder 2"/>
+          <p:cNvPr id="244738645" name="Text Placeholder 2"/>
           <p:cNvSpPr>
             <a:spLocks noGrp="1"/>
           </p:cNvSpPr>
@@ -14174,7 +14718,7 @@
 </p:sld>
 </file>
 
-<file path=ppt/slides/slide2.xml><?xml version="1.0" encoding="utf-8"?>
+<file path=ppt/slides/slide22.xml><?xml version="1.0" encoding="utf-8"?>
 <p:sld xmlns:a="http://schemas.openxmlformats.org/drawingml/2006/main" xmlns:r="http://schemas.openxmlformats.org/officeDocument/2006/relationships" xmlns:p="http://schemas.openxmlformats.org/presentationml/2006/main" xmlns:m="http://schemas.openxmlformats.org/officeDocument/2006/math" xmlns:w="http://schemas.openxmlformats.org/wordprocessingml/2006/main" xmlns:mc="http://schemas.openxmlformats.org/markup-compatibility/2006" showMasterPhAnim="0" showMasterSp="1" show="1">
   <p:cSld name="">
     <p:spTree>
@@ -14193,7 +14737,7 @@
       </p:grpSpPr>
       <p:sp>
         <p:nvSpPr>
-          <p:cNvPr id="1023946637" name="Title 1"/>
+          <p:cNvPr id="291833595" name="Title 1"/>
           <p:cNvSpPr>
             <a:spLocks noGrp="1"/>
           </p:cNvSpPr>
@@ -14211,7 +14755,7 @@
             </a:pPr>
             <a:r>
               <a:rPr/>
-              <a:t>Outline</a:t>
+              <a:t>Determining Variables</a:t>
             </a:r>
             <a:endParaRPr/>
           </a:p>
@@ -14219,7 +14763,7 @@
       </p:sp>
       <p:sp>
         <p:nvSpPr>
-          <p:cNvPr id="1051192037" name="Content Placeholder 2"/>
+          <p:cNvPr id="1084171926" name="Content Placeholder 2"/>
           <p:cNvSpPr>
             <a:spLocks noGrp="1"/>
           </p:cNvSpPr>
@@ -14237,141 +14781,6 @@
             </a:pPr>
             <a:r>
               <a:rPr/>
-              <a:t>Neural Networks</a:t>
-            </a:r>
-            <a:endParaRPr/>
-          </a:p>
-          <a:p>
-            <a:pPr lvl="1">
-              <a:defRPr/>
-            </a:pPr>
-            <a:r>
-              <a:rPr/>
-              <a:t>Perceptron</a:t>
-            </a:r>
-            <a:endParaRPr/>
-          </a:p>
-          <a:p>
-            <a:pPr lvl="1">
-              <a:defRPr/>
-            </a:pPr>
-            <a:r>
-              <a:rPr/>
-              <a:t>Multi-Layer Perceptron</a:t>
-            </a:r>
-            <a:endParaRPr/>
-          </a:p>
-          <a:p>
-            <a:pPr lvl="1">
-              <a:defRPr/>
-            </a:pPr>
-            <a:r>
-              <a:rPr/>
-              <a:t>Recursive Neural Networks (RNNs)</a:t>
-            </a:r>
-            <a:endParaRPr/>
-          </a:p>
-          <a:p>
-            <a:pPr lvl="1">
-              <a:defRPr/>
-            </a:pPr>
-            <a:r>
-              <a:rPr/>
-              <a:t>NeuralODE</a:t>
-            </a:r>
-            <a:endParaRPr/>
-          </a:p>
-          <a:p>
-            <a:pPr lvl="0">
-              <a:defRPr/>
-            </a:pPr>
-            <a:r>
-              <a:rPr/>
-              <a:t>Gathering Data</a:t>
-            </a:r>
-            <a:endParaRPr/>
-          </a:p>
-        </p:txBody>
-      </p:sp>
-    </p:spTree>
-  </p:cSld>
-  <p:clrMapOvr>
-    <a:masterClrMapping/>
-  </p:clrMapOvr>
-  <mc:AlternateContent xmlns:mc="http://schemas.openxmlformats.org/markup-compatibility/2006">
-    <mc:Choice xmlns:p159="http://schemas.microsoft.com/office/powerpoint/2015/09/main" xmlns:p14="http://schemas.microsoft.com/office/powerpoint/2010/main" Requires="p159">
-      <p:transition p14:dur="2000" advClick="1"/>
-    </mc:Choice>
-    <mc:Fallback>
-      <p:transition advClick="1"/>
-    </mc:Fallback>
-  </mc:AlternateContent>
-</p:sld>
-</file>
-
-<file path=ppt/slides/slide20.xml><?xml version="1.0" encoding="utf-8"?>
-<p:sld xmlns:a="http://schemas.openxmlformats.org/drawingml/2006/main" xmlns:r="http://schemas.openxmlformats.org/officeDocument/2006/relationships" xmlns:p="http://schemas.openxmlformats.org/presentationml/2006/main" xmlns:m="http://schemas.openxmlformats.org/officeDocument/2006/math" xmlns:w="http://schemas.openxmlformats.org/wordprocessingml/2006/main" xmlns:mc="http://schemas.openxmlformats.org/markup-compatibility/2006" showMasterPhAnim="0" showMasterSp="1" show="1">
-  <p:cSld name="">
-    <p:spTree>
-      <p:nvGrpSpPr>
-        <p:cNvPr id="1" name=""/>
-        <p:cNvGrpSpPr/>
-        <p:nvPr/>
-      </p:nvGrpSpPr>
-      <p:grpSpPr bwMode="auto">
-        <a:xfrm>
-          <a:off x="0" y="0"/>
-          <a:ext cx="0" cy="0"/>
-          <a:chOff x="0" y="0"/>
-          <a:chExt cx="0" cy="0"/>
-        </a:xfrm>
-      </p:grpSpPr>
-      <p:sp>
-        <p:nvSpPr>
-          <p:cNvPr id="315414074" name="Title 1"/>
-          <p:cNvSpPr>
-            <a:spLocks noGrp="1"/>
-          </p:cNvSpPr>
-          <p:nvPr>
-            <p:ph type="title"/>
-          </p:nvPr>
-        </p:nvSpPr>
-        <p:spPr bwMode="auto"/>
-        <p:txBody>
-          <a:bodyPr/>
-          <a:lstStyle/>
-          <a:p>
-            <a:pPr>
-              <a:defRPr/>
-            </a:pPr>
-            <a:r>
-              <a:rPr/>
-              <a:t>Determining Variables</a:t>
-            </a:r>
-            <a:endParaRPr/>
-          </a:p>
-        </p:txBody>
-      </p:sp>
-      <p:sp>
-        <p:nvSpPr>
-          <p:cNvPr id="1011549612" name="Content Placeholder 2"/>
-          <p:cNvSpPr>
-            <a:spLocks noGrp="1"/>
-          </p:cNvSpPr>
-          <p:nvPr>
-            <p:ph idx="1"/>
-          </p:nvPr>
-        </p:nvSpPr>
-        <p:spPr bwMode="auto"/>
-        <p:txBody>
-          <a:bodyPr/>
-          <a:lstStyle/>
-          <a:p>
-            <a:pPr>
-              <a:defRPr/>
-            </a:pPr>
-            <a:r>
-              <a:rPr/>
               <a:t>input_history.txt</a:t>
             </a:r>
             <a:endParaRPr/>
@@ -14430,7 +14839,7 @@
       </p:sp>
       <p:pic>
         <p:nvPicPr>
-          <p:cNvPr id="203379021" name=""/>
+          <p:cNvPr id="739542347" name=""/>
           <p:cNvPicPr>
             <a:picLocks noChangeAspect="1"/>
           </p:cNvPicPr>
@@ -14466,7 +14875,7 @@
 </p:sld>
 </file>
 
-<file path=ppt/slides/slide21.xml><?xml version="1.0" encoding="utf-8"?>
+<file path=ppt/slides/slide23.xml><?xml version="1.0" encoding="utf-8"?>
 <p:sld xmlns:a="http://schemas.openxmlformats.org/drawingml/2006/main" xmlns:r="http://schemas.openxmlformats.org/officeDocument/2006/relationships" xmlns:p="http://schemas.openxmlformats.org/presentationml/2006/main" xmlns:m="http://schemas.openxmlformats.org/officeDocument/2006/math" xmlns:w="http://schemas.openxmlformats.org/wordprocessingml/2006/main" xmlns:mc="http://schemas.openxmlformats.org/markup-compatibility/2006" showMasterPhAnim="0" showMasterSp="1" show="1">
   <p:cSld name="">
     <p:spTree>
@@ -14485,7 +14894,7 @@
       </p:grpSpPr>
       <p:sp>
         <p:nvSpPr>
-          <p:cNvPr id="1672184912" name="Title 1"/>
+          <p:cNvPr id="1515933201" name="Title 1"/>
           <p:cNvSpPr>
             <a:spLocks noGrp="1"/>
           </p:cNvSpPr>
@@ -14511,7 +14920,7 @@
       </p:sp>
       <p:sp>
         <p:nvSpPr>
-          <p:cNvPr id="1375521626" name="Content Placeholder 2"/>
+          <p:cNvPr id="1331608325" name="Content Placeholder 2"/>
           <p:cNvSpPr>
             <a:spLocks noGrp="1"/>
           </p:cNvSpPr>
@@ -14571,7 +14980,7 @@
       </p:sp>
       <p:sp>
         <p:nvSpPr>
-          <p:cNvPr id="113208436" name=""/>
+          <p:cNvPr id="1943067380" name=""/>
           <p:cNvSpPr txBox="1"/>
           <p:nvPr/>
         </p:nvSpPr>
@@ -14635,7 +15044,7 @@
       </p:sp>
       <p:sp>
         <p:nvSpPr>
-          <p:cNvPr id="1628367640" name="Content Placeholder 3"/>
+          <p:cNvPr id="1669173678" name="Content Placeholder 3"/>
           <p:cNvSpPr>
             <a:spLocks noGrp="1"/>
           </p:cNvSpPr>
@@ -14913,7 +15322,7 @@
       </p:sp>
       <p:sp>
         <p:nvSpPr>
-          <p:cNvPr id="988916056" name=""/>
+          <p:cNvPr id="1371260429" name=""/>
           <p:cNvSpPr/>
           <p:nvPr/>
         </p:nvSpPr>
@@ -14982,7 +15391,7 @@
       </p:grpSpPr>
       <p:sp>
         <p:nvSpPr>
-          <p:cNvPr id="490777184" name="Title 1"/>
+          <p:cNvPr id="1367172788" name="Title 1"/>
           <p:cNvSpPr>
             <a:spLocks noGrp="1"/>
           </p:cNvSpPr>
@@ -15012,7 +15421,7 @@
       </p:sp>
       <p:sp>
         <p:nvSpPr>
-          <p:cNvPr id="311349970" name="Text Placeholder 2"/>
+          <p:cNvPr id="124632292" name="Text Placeholder 2"/>
           <p:cNvSpPr>
             <a:spLocks noGrp="1"/>
           </p:cNvSpPr>
@@ -15163,7 +15572,7 @@
       </p:grpSpPr>
       <p:sp>
         <p:nvSpPr>
-          <p:cNvPr id="1626536755" name="Title 1"/>
+          <p:cNvPr id="1416792491" name="Title 1"/>
           <p:cNvSpPr>
             <a:spLocks noGrp="1"/>
           </p:cNvSpPr>
@@ -15189,7 +15598,7 @@
       </p:sp>
       <p:sp>
         <p:nvSpPr>
-          <p:cNvPr id="626798918" name="Content Placeholder 2"/>
+          <p:cNvPr id="477610709" name="Content Placeholder 2"/>
           <p:cNvSpPr>
             <a:spLocks noGrp="1"/>
           </p:cNvSpPr>
@@ -15268,7 +15677,7 @@
       </p:sp>
       <p:pic>
         <p:nvPicPr>
-          <p:cNvPr id="1272906809" name=""/>
+          <p:cNvPr id="304201695" name=""/>
           <p:cNvPicPr>
             <a:picLocks noChangeAspect="1"/>
           </p:cNvPicPr>
@@ -15325,7 +15734,7 @@
       </p:grpSpPr>
       <p:sp>
         <p:nvSpPr>
-          <p:cNvPr id="2130204756" name="Title 1"/>
+          <p:cNvPr id="1424574249" name="Title 1"/>
           <p:cNvSpPr>
             <a:spLocks noGrp="1"/>
           </p:cNvSpPr>
@@ -15351,7 +15760,7 @@
       </p:sp>
       <p:sp>
         <p:nvSpPr>
-          <p:cNvPr id="448414006" name="Text Placeholder 2"/>
+          <p:cNvPr id="1552073840" name="Text Placeholder 2"/>
           <p:cNvSpPr>
             <a:spLocks noGrp="1"/>
           </p:cNvSpPr>
@@ -15502,7 +15911,7 @@
       </p:grpSpPr>
       <p:sp>
         <p:nvSpPr>
-          <p:cNvPr id="1640651660" name="Title 1"/>
+          <p:cNvPr id="1203613041" name="Title 1"/>
           <p:cNvSpPr>
             <a:spLocks noGrp="1"/>
           </p:cNvSpPr>
@@ -15528,7 +15937,7 @@
       </p:sp>
       <p:sp>
         <p:nvSpPr>
-          <p:cNvPr id="412976423" name="Content Placeholder 2"/>
+          <p:cNvPr id="1532547851" name="Content Placeholder 2"/>
           <p:cNvSpPr>
             <a:spLocks noGrp="1"/>
           </p:cNvSpPr>
@@ -15621,7 +16030,7 @@
       </p:sp>
       <p:pic>
         <p:nvPicPr>
-          <p:cNvPr id="999787189" name=""/>
+          <p:cNvPr id="1850809609" name=""/>
           <p:cNvPicPr>
             <a:picLocks noChangeAspect="1"/>
           </p:cNvPicPr>
@@ -15678,7 +16087,7 @@
       </p:grpSpPr>
       <p:sp>
         <p:nvSpPr>
-          <p:cNvPr id="2034921742" name="Title 1"/>
+          <p:cNvPr id="1430845868" name="Title 1"/>
           <p:cNvSpPr>
             <a:spLocks noGrp="1"/>
           </p:cNvSpPr>
@@ -15708,7 +16117,7 @@
       </p:sp>
       <p:sp>
         <p:nvSpPr>
-          <p:cNvPr id="1093481147" name=""/>
+          <p:cNvPr id="258153886" name=""/>
           <p:cNvSpPr txBox="1"/>
           <p:nvPr/>
         </p:nvSpPr>
@@ -15756,7 +16165,7 @@
       </p:sp>
       <p:sp>
         <p:nvSpPr>
-          <p:cNvPr id="492414946" name=""/>
+          <p:cNvPr id="1382976605" name=""/>
           <p:cNvSpPr txBox="1"/>
           <p:nvPr/>
         </p:nvSpPr>
@@ -15804,7 +16213,7 @@
       </p:sp>
       <p:sp>
         <p:nvSpPr>
-          <p:cNvPr id="1444759641" name=""/>
+          <p:cNvPr id="2142761040" name=""/>
           <p:cNvSpPr txBox="1"/>
           <p:nvPr/>
         </p:nvSpPr>
@@ -15852,7 +16261,7 @@
       </p:sp>
       <p:sp>
         <p:nvSpPr>
-          <p:cNvPr id="1044980430" name=""/>
+          <p:cNvPr id="1371667432" name=""/>
           <p:cNvSpPr txBox="1"/>
           <p:nvPr/>
         </p:nvSpPr>
@@ -15900,7 +16309,7 @@
       </p:sp>
       <p:sp>
         <p:nvSpPr>
-          <p:cNvPr id="1557187866" name=""/>
+          <p:cNvPr id="298102342" name=""/>
           <p:cNvSpPr txBox="1"/>
           <p:nvPr/>
         </p:nvSpPr>
@@ -15968,7 +16377,7 @@
       </p:sp>
       <p:sp>
         <p:nvSpPr>
-          <p:cNvPr id="2042627820" name=""/>
+          <p:cNvPr id="795979261" name=""/>
           <p:cNvSpPr txBox="1"/>
           <p:nvPr/>
         </p:nvSpPr>
@@ -16016,10 +16425,10 @@
       </p:sp>
       <p:cxnSp>
         <p:nvCxnSpPr>
-          <p:cNvPr id="479911784" name=""/>
+          <p:cNvPr id="1726256828" name=""/>
           <p:cNvCxnSpPr>
-            <a:stCxn id="1093481147" idx="3"/>
-            <a:endCxn id="1557187866" idx="1"/>
+            <a:stCxn id="258153886" idx="3"/>
+            <a:endCxn id="298102342" idx="1"/>
           </p:cNvCxnSpPr>
           <p:nvPr/>
         </p:nvCxnSpPr>
@@ -16056,9 +16465,9 @@
       </p:cxnSp>
       <p:cxnSp>
         <p:nvCxnSpPr>
-          <p:cNvPr id="1215609491" name=""/>
+          <p:cNvPr id="1505570939" name=""/>
           <p:cNvCxnSpPr>
-            <a:endCxn id="1557187866" idx="1"/>
+            <a:endCxn id="298102342" idx="1"/>
           </p:cNvCxnSpPr>
           <p:nvPr/>
         </p:nvCxnSpPr>
@@ -16095,9 +16504,9 @@
       </p:cxnSp>
       <p:cxnSp>
         <p:nvCxnSpPr>
-          <p:cNvPr id="92762146" name=""/>
+          <p:cNvPr id="1711787753" name=""/>
           <p:cNvCxnSpPr>
-            <a:endCxn id="1557187866" idx="1"/>
+            <a:endCxn id="298102342" idx="1"/>
           </p:cNvCxnSpPr>
           <p:nvPr/>
         </p:nvCxnSpPr>
@@ -16134,10 +16543,10 @@
       </p:cxnSp>
       <p:cxnSp>
         <p:nvCxnSpPr>
-          <p:cNvPr id="691235629" name=""/>
+          <p:cNvPr id="361862166" name=""/>
           <p:cNvCxnSpPr>
-            <a:stCxn id="1044980430" idx="3"/>
-            <a:endCxn id="1557187866" idx="1"/>
+            <a:stCxn id="1371667432" idx="3"/>
+            <a:endCxn id="298102342" idx="1"/>
           </p:cNvCxnSpPr>
           <p:nvPr/>
         </p:nvCxnSpPr>
@@ -16174,7 +16583,7 @@
       </p:cxnSp>
       <p:sp>
         <p:nvSpPr>
-          <p:cNvPr id="671039110" name=""/>
+          <p:cNvPr id="571885024" name=""/>
           <p:cNvSpPr txBox="1"/>
           <p:nvPr/>
         </p:nvSpPr>
@@ -16206,7 +16615,7 @@
       </p:sp>
       <p:sp>
         <p:nvSpPr>
-          <p:cNvPr id="778550811" name=""/>
+          <p:cNvPr id="848477228" name=""/>
           <p:cNvSpPr txBox="1"/>
           <p:nvPr/>
         </p:nvSpPr>
@@ -16238,7 +16647,7 @@
       </p:sp>
       <p:sp>
         <p:nvSpPr>
-          <p:cNvPr id="265958143" name=""/>
+          <p:cNvPr id="381150524" name=""/>
           <p:cNvSpPr txBox="1"/>
           <p:nvPr/>
         </p:nvSpPr>
@@ -16270,7 +16679,7 @@
       </p:sp>
       <p:sp>
         <p:nvSpPr>
-          <p:cNvPr id="147923538" name=""/>
+          <p:cNvPr id="210241004" name=""/>
           <p:cNvSpPr txBox="1"/>
           <p:nvPr/>
         </p:nvSpPr>
@@ -16302,9 +16711,9 @@
       </p:sp>
       <p:cxnSp>
         <p:nvCxnSpPr>
-          <p:cNvPr id="1595706191" name=""/>
+          <p:cNvPr id="278914467" name=""/>
           <p:cNvCxnSpPr>
-            <a:endCxn id="2042627820" idx="1"/>
+            <a:endCxn id="795979261" idx="1"/>
           </p:cNvCxnSpPr>
           <p:nvPr/>
         </p:nvCxnSpPr>
@@ -16374,7 +16783,7 @@
       </p:grpSpPr>
       <p:sp>
         <p:nvSpPr>
-          <p:cNvPr id="1256944070" name="Title 1"/>
+          <p:cNvPr id="1240146830" name="Title 1"/>
           <p:cNvSpPr>
             <a:spLocks noGrp="1"/>
           </p:cNvSpPr>
@@ -16404,7 +16813,7 @@
       </p:sp>
       <p:sp>
         <p:nvSpPr>
-          <p:cNvPr id="1776869327" name=""/>
+          <p:cNvPr id="678960465" name=""/>
           <p:cNvSpPr txBox="1"/>
           <p:nvPr/>
         </p:nvSpPr>
@@ -16452,7 +16861,7 @@
       </p:sp>
       <p:sp>
         <p:nvSpPr>
-          <p:cNvPr id="1648641763" name=""/>
+          <p:cNvPr id="359210952" name=""/>
           <p:cNvSpPr txBox="1"/>
           <p:nvPr/>
         </p:nvSpPr>
@@ -16500,7 +16909,7 @@
       </p:sp>
       <p:sp>
         <p:nvSpPr>
-          <p:cNvPr id="1927506554" name=""/>
+          <p:cNvPr id="1471361314" name=""/>
           <p:cNvSpPr txBox="1"/>
           <p:nvPr/>
         </p:nvSpPr>
@@ -16548,7 +16957,7 @@
       </p:sp>
       <p:sp>
         <p:nvSpPr>
-          <p:cNvPr id="1682536998" name=""/>
+          <p:cNvPr id="1517544311" name=""/>
           <p:cNvSpPr txBox="1"/>
           <p:nvPr/>
         </p:nvSpPr>
@@ -16596,7 +17005,7 @@
       </p:sp>
       <p:sp>
         <p:nvSpPr>
-          <p:cNvPr id="1439429880" name=""/>
+          <p:cNvPr id="2062485223" name=""/>
           <p:cNvSpPr txBox="1"/>
           <p:nvPr/>
         </p:nvSpPr>
@@ -16664,7 +17073,7 @@
       </p:sp>
       <p:sp>
         <p:nvSpPr>
-          <p:cNvPr id="1257857412" name=""/>
+          <p:cNvPr id="1520985512" name=""/>
           <p:cNvSpPr txBox="1"/>
           <p:nvPr/>
         </p:nvSpPr>
@@ -16712,10 +17121,10 @@
       </p:sp>
       <p:cxnSp>
         <p:nvCxnSpPr>
-          <p:cNvPr id="661168819" name=""/>
+          <p:cNvPr id="268121171" name=""/>
           <p:cNvCxnSpPr>
-            <a:stCxn id="1776869327" idx="3"/>
-            <a:endCxn id="1439429880" idx="1"/>
+            <a:stCxn id="678960465" idx="3"/>
+            <a:endCxn id="2062485223" idx="1"/>
           </p:cNvCxnSpPr>
           <p:nvPr/>
         </p:nvCxnSpPr>
@@ -16752,9 +17161,9 @@
       </p:cxnSp>
       <p:cxnSp>
         <p:nvCxnSpPr>
-          <p:cNvPr id="1205793704" name=""/>
+          <p:cNvPr id="1365898242" name=""/>
           <p:cNvCxnSpPr>
-            <a:endCxn id="1439429880" idx="1"/>
+            <a:endCxn id="2062485223" idx="1"/>
           </p:cNvCxnSpPr>
           <p:nvPr/>
         </p:nvCxnSpPr>
@@ -16791,9 +17200,9 @@
       </p:cxnSp>
       <p:cxnSp>
         <p:nvCxnSpPr>
-          <p:cNvPr id="2014002803" name=""/>
+          <p:cNvPr id="1955377834" name=""/>
           <p:cNvCxnSpPr>
-            <a:endCxn id="1439429880" idx="1"/>
+            <a:endCxn id="2062485223" idx="1"/>
           </p:cNvCxnSpPr>
           <p:nvPr/>
         </p:nvCxnSpPr>
@@ -16830,10 +17239,10 @@
       </p:cxnSp>
       <p:cxnSp>
         <p:nvCxnSpPr>
-          <p:cNvPr id="118813855" name=""/>
+          <p:cNvPr id="165621828" name=""/>
           <p:cNvCxnSpPr>
-            <a:stCxn id="1682536998" idx="3"/>
-            <a:endCxn id="1439429880" idx="1"/>
+            <a:stCxn id="1517544311" idx="3"/>
+            <a:endCxn id="2062485223" idx="1"/>
           </p:cNvCxnSpPr>
           <p:nvPr/>
         </p:nvCxnSpPr>
@@ -16870,7 +17279,7 @@
       </p:cxnSp>
       <p:sp>
         <p:nvSpPr>
-          <p:cNvPr id="96109018" name=""/>
+          <p:cNvPr id="317543457" name=""/>
           <p:cNvSpPr txBox="1"/>
           <p:nvPr/>
         </p:nvSpPr>
@@ -16902,7 +17311,7 @@
       </p:sp>
       <p:sp>
         <p:nvSpPr>
-          <p:cNvPr id="1796217023" name=""/>
+          <p:cNvPr id="1116104526" name=""/>
           <p:cNvSpPr txBox="1"/>
           <p:nvPr/>
         </p:nvSpPr>
@@ -16934,7 +17343,7 @@
       </p:sp>
       <p:sp>
         <p:nvSpPr>
-          <p:cNvPr id="26057966" name=""/>
+          <p:cNvPr id="725910915" name=""/>
           <p:cNvSpPr txBox="1"/>
           <p:nvPr/>
         </p:nvSpPr>
@@ -16966,7 +17375,7 @@
       </p:sp>
       <p:sp>
         <p:nvSpPr>
-          <p:cNvPr id="332867351" name=""/>
+          <p:cNvPr id="321043997" name=""/>
           <p:cNvSpPr txBox="1"/>
           <p:nvPr/>
         </p:nvSpPr>
@@ -16998,9 +17407,9 @@
       </p:sp>
       <p:cxnSp>
         <p:nvCxnSpPr>
-          <p:cNvPr id="625169101" name=""/>
+          <p:cNvPr id="444864331" name=""/>
           <p:cNvCxnSpPr>
-            <a:endCxn id="1257857412" idx="1"/>
+            <a:endCxn id="1520985512" idx="1"/>
           </p:cNvCxnSpPr>
           <p:nvPr/>
         </p:nvCxnSpPr>
@@ -17070,7 +17479,7 @@
       </p:grpSpPr>
       <p:sp>
         <p:nvSpPr>
-          <p:cNvPr id="1850400495" name="Title 1"/>
+          <p:cNvPr id="1491743608" name="Title 1"/>
           <p:cNvSpPr>
             <a:spLocks noGrp="1"/>
           </p:cNvSpPr>
@@ -17096,7 +17505,7 @@
       </p:sp>
       <p:pic>
         <p:nvPicPr>
-          <p:cNvPr id="934711135" name=""/>
+          <p:cNvPr id="1164673713" name=""/>
           <p:cNvPicPr>
             <a:picLocks noChangeAspect="1"/>
           </p:cNvPicPr>

</xml_diff>